<commit_message>
docs(handover): USER-GUIDE them onboarding truong moi (CR-034)
- slide moi: So GD tao truong + admin -> admin tu tao GV -> GVCN cap TK PH -> /dept/usage giam sat
- bang tai khoan test them sogd@demo.scn; workflow GVCN them cap TK PH tren roster
- role matrix ghi ro So GD chi quan tri truong + usage, khong vao nghiep vu lop

Generated with [Devin](https://devin.ai)

Co-Authored-By: Devin <158243242+devin-ai-integration[bot]@users.noreply.github.com>
</commit_message>
<xml_diff>
--- a/docs/handover/USER-GUIDE-vieschool.pptx
+++ b/docs/handover/USER-GUIDE-vieschool.pptx
@@ -21,9 +21,10 @@
     <p:sldId id="269" r:id="rId15"/>
     <p:sldId id="270" r:id="rId16"/>
     <p:sldId id="271" r:id="rId17"/>
+    <p:sldId id="272" r:id="rId18"/>
   </p:sldIdLst>
   <p:notesMasterIdLst>
-    <p:notesMasterId r:id="rId18"/>
+    <p:notesMasterId r:id="rId19"/>
   </p:notesMasterIdLst>
   <p:sldSz cx="12188952" cy="6858000"/>
   <p:notesSz cx="6858000" cy="12188952"/>
@@ -1157,6 +1158,94 @@
             <a:fld id="{F7021451-1387-4CA6-816F-3879F97B5CBC}" type="slidenum">
               <a:rPr lang="en-US"/>
               <a:t>16</a:t>
+            </a:fld>
+            <a:endParaRPr lang="en-US"/>
+          </a:p>
+        </p:txBody>
+      </p:sp>
+    </p:spTree>
+    <p:extLst>
+      <p:ext uri="{BB962C8B-B14F-4D97-AF65-F5344CB8AC3E}">
+        <p14:creationId xmlns:p14="http://schemas.microsoft.com/office/powerpoint/2010/main" val="1024086991"/>
+      </p:ext>
+    </p:extLst>
+  </p:cSld>
+  <p:clrMapOvr>
+    <a:masterClrMapping/>
+  </p:clrMapOvr>
+</p:notes>
+</file>
+
+<file path=ppt/notesSlides/notesSlide17.xml><?xml version="1.0" encoding="utf-8"?>
+<p:notes xmlns:a="http://schemas.openxmlformats.org/drawingml/2006/main" xmlns:r="http://schemas.openxmlformats.org/officeDocument/2006/relationships" xmlns:p="http://schemas.openxmlformats.org/presentationml/2006/main">
+  <p:cSld>
+    <p:spTree>
+      <p:nvGrpSpPr>
+        <p:cNvPr id="1" name=""/>
+        <p:cNvGrpSpPr/>
+        <p:nvPr/>
+      </p:nvGrpSpPr>
+      <p:grpSpPr>
+        <a:xfrm>
+          <a:off x="0" y="0"/>
+          <a:ext cx="0" cy="0"/>
+          <a:chOff x="0" y="0"/>
+          <a:chExt cx="0" cy="0"/>
+        </a:xfrm>
+      </p:grpSpPr>
+      <p:sp>
+        <p:nvSpPr>
+          <p:cNvPr id="2" name="Slide Image Placeholder 1"/>
+          <p:cNvSpPr>
+            <a:spLocks noGrp="1" noRot="1" noChangeAspect="1"/>
+          </p:cNvSpPr>
+          <p:nvPr>
+            <p:ph type="sldImg"/>
+          </p:nvPr>
+        </p:nvSpPr>
+        <p:spPr/>
+      </p:sp>
+      <p:sp>
+        <p:nvSpPr>
+          <p:cNvPr id="3" name="Notes Placeholder 2"/>
+          <p:cNvSpPr>
+            <a:spLocks noGrp="1"/>
+          </p:cNvSpPr>
+          <p:nvPr>
+            <p:ph type="body" idx="1"/>
+          </p:nvPr>
+        </p:nvSpPr>
+        <p:spPr/>
+        <p:txBody>
+          <a:bodyPr/>
+          <a:lstStyle/>
+          <a:p>
+            <a:r>
+              <a:rPr lang="en-US" dirty="0"/>
+              <a:t/>
+            </a:r>
+            <a:endParaRPr lang="en-US" dirty="0"/>
+          </a:p>
+        </p:txBody>
+      </p:sp>
+      <p:sp>
+        <p:nvSpPr>
+          <p:cNvPr id="4" name="Slide Number Placeholder 3"/>
+          <p:cNvSpPr>
+            <a:spLocks noGrp="1"/>
+          </p:cNvSpPr>
+          <p:nvPr>
+            <p:ph type="sldNum" sz="quarter" idx="10"/>
+          </p:nvPr>
+        </p:nvSpPr>
+        <p:spPr/>
+        <p:txBody>
+          <a:bodyPr/>
+          <a:lstStyle/>
+          <a:p>
+            <a:fld id="{F7021451-1387-4CA6-816F-3879F97B5CBC}" type="slidenum">
+              <a:rPr lang="en-US"/>
+              <a:t>17</a:t>
             </a:fld>
             <a:endParaRPr lang="en-US"/>
           </a:p>
@@ -3686,7 +3775,7 @@
                 <a:ea typeface="Segoe UI" pitchFamily="34" charset="-122"/>
                 <a:cs typeface="Segoe UI" pitchFamily="34" charset="-120"/>
               </a:rPr>
-              <a:t>ĐIỂM NỔI BẬT</a:t>
+              <a:t>ONBOARDING TRƯỜNG MỚI</a:t>
             </a:r>
             <a:endParaRPr lang="en-US" sz="1100" dirty="0"/>
           </a:p>
@@ -3725,7 +3814,7 @@
                 <a:ea typeface="Segoe UI" pitchFamily="34" charset="-122"/>
                 <a:cs typeface="Segoe UI" pitchFamily="34" charset="-120"/>
               </a:rPr>
-              <a:t>Khác biệt so với nền tảng thông thường</a:t>
+              <a:t>Tự phục vụ: Sở GD tạo trường → admin trường tự vận hành</a:t>
             </a:r>
             <a:endParaRPr lang="en-US" sz="2600" dirty="0"/>
           </a:p>
@@ -3783,15 +3872,15 @@
               <a:buChar char="•"/>
             </a:pPr>
             <a:r>
-              <a:rPr lang="en-US" sz="1350" dirty="0">
-                <a:solidFill>
-                  <a:srgbClr val="0F766E"/>
-                </a:solidFill>
-                <a:latin typeface="Segoe UI" pitchFamily="34" charset="0"/>
-                <a:ea typeface="Segoe UI" pitchFamily="34" charset="-122"/>
-                <a:cs typeface="Segoe UI" pitchFamily="34" charset="-120"/>
-              </a:rPr>
-              <a:t>Bám quy định thật: YCCĐ CTGDPT 2018 chi tiết đến strand; TT22/2021 (HK1/HK2/năm tách, không KT giấy lớp 1-3 giữa kì); TT27/2025</a:t>
+              <a:rPr lang="en-US" sz="1350" b="1" dirty="0">
+                <a:solidFill>
+                  <a:srgbClr val="0F172A"/>
+                </a:solidFill>
+                <a:latin typeface="Segoe UI" pitchFamily="34" charset="0"/>
+                <a:ea typeface="Segoe UI" pitchFamily="34" charset="-122"/>
+                <a:cs typeface="Segoe UI" pitchFamily="34" charset="-120"/>
+              </a:rPr>
+              <a:t>Bước 1 - Sở GD/admin hệ thống: /dept/schools → 'Tạo trường'</a:t>
             </a:r>
             <a:endParaRPr lang="en-US" sz="1350" dirty="0"/>
           </a:p>
@@ -3806,13 +3895,76 @@
             <a:r>
               <a:rPr lang="en-US" sz="1350" dirty="0">
                 <a:solidFill>
-                  <a:srgbClr val="0F766E"/>
-                </a:solidFill>
-                <a:latin typeface="Segoe UI" pitchFamily="34" charset="0"/>
-                <a:ea typeface="Segoe UI" pitchFamily="34" charset="-122"/>
-                <a:cs typeface="Segoe UI" pitchFamily="34" charset="-120"/>
-              </a:rPr>
-              <a:t>Ngân hàng trường + duyệt 2 lớp + audit trail - kiểm soát chất lượng đề như trường thật vận hành</a:t>
+                  <a:srgbClr val="0F172A"/>
+                </a:solidFill>
+                <a:latin typeface="Segoe UI" pitchFamily="34" charset="0"/>
+                <a:ea typeface="Segoe UI" pitchFamily="34" charset="-122"/>
+                <a:cs typeface="Segoe UI" pitchFamily="34" charset="-120"/>
+              </a:rPr>
+              <a:t>[object Object]</a:t>
+            </a:r>
+            <a:endParaRPr lang="en-US" sz="1350" dirty="0"/>
+          </a:p>
+          <a:p>
+            <a:pPr marL="381000" indent="-381000">
+              <a:spcAft>
+                <a:spcPts val="800"/>
+              </a:spcAft>
+              <a:buSzPct val="100000"/>
+              <a:buChar char="–"/>
+            </a:pPr>
+            <a:r>
+              <a:rPr lang="en-US" sz="1200" dirty="0">
+                <a:solidFill>
+                  <a:srgbClr val="475569"/>
+                </a:solidFill>
+                <a:latin typeface="Segoe UI" pitchFamily="34" charset="0"/>
+                <a:ea typeface="Segoe UI" pitchFamily="34" charset="-122"/>
+                <a:cs typeface="Segoe UI" pitchFamily="34" charset="-120"/>
+              </a:rPr>
+              <a:t>Nhập tên, mã, cấp học (Tiểu học/THCS/THPT), email + mật khẩu admin trường (vai trò BGH)</a:t>
+            </a:r>
+            <a:endParaRPr lang="en-US" sz="1350" dirty="0"/>
+          </a:p>
+          <a:p>
+            <a:pPr marL="381000" indent="-381000">
+              <a:spcAft>
+                <a:spcPts val="800"/>
+              </a:spcAft>
+              <a:buSzPct val="100000"/>
+              <a:buChar char="–"/>
+            </a:pPr>
+            <a:r>
+              <a:rPr lang="en-US" sz="1200" dirty="0">
+                <a:solidFill>
+                  <a:srgbClr val="475569"/>
+                </a:solidFill>
+                <a:latin typeface="Segoe UI" pitchFamily="34" charset="0"/>
+                <a:ea typeface="Segoe UI" pitchFamily="34" charset="-122"/>
+                <a:cs typeface="Segoe UI" pitchFamily="34" charset="-120"/>
+              </a:rPr>
+              <a:t>Tick 'Seed dữ liệu mẫu' → hệ thống tự tạo năm học 2026-2027, 2 tổ CM, bộ môn theo cấp, lớp mẫu + HS mẫu</a:t>
+            </a:r>
+            <a:endParaRPr lang="en-US" sz="1350" dirty="0"/>
+          </a:p>
+          <a:p>
+            <a:pPr marL="381000" indent="-381000">
+              <a:spcAft>
+                <a:spcPts val="800"/>
+              </a:spcAft>
+              <a:buSzPct val="100000"/>
+              <a:buChar char="–"/>
+            </a:pPr>
+            <a:r>
+              <a:rPr lang="en-US" sz="1200" dirty="0">
+                <a:solidFill>
+                  <a:srgbClr val="475569"/>
+                </a:solidFill>
+                <a:latin typeface="Segoe UI" pitchFamily="34" charset="0"/>
+                <a:ea typeface="Segoe UI" pitchFamily="34" charset="-122"/>
+                <a:cs typeface="Segoe UI" pitchFamily="34" charset="-120"/>
+              </a:rPr>
+              <a:t>Lỗi giữa chừng → hệ thống rollback và báo rõ phần chưa dọn - không trường 'nửa vời'</a:t>
             </a:r>
             <a:endParaRPr lang="en-US" sz="1350" dirty="0"/>
           </a:p>
@@ -3825,15 +3977,15 @@
               <a:buChar char="•"/>
             </a:pPr>
             <a:r>
-              <a:rPr lang="en-US" sz="1350" dirty="0">
-                <a:solidFill>
-                  <a:srgbClr val="0F766E"/>
-                </a:solidFill>
-                <a:latin typeface="Segoe UI" pitchFamily="34" charset="0"/>
-                <a:ea typeface="Segoe UI" pitchFamily="34" charset="-122"/>
-                <a:cs typeface="Segoe UI" pitchFamily="34" charset="-120"/>
-              </a:rPr>
-              <a:t>Hình học deterministic (không AI ảo) + xuất Word Equation native - in thi thật dùng được ngay</a:t>
+              <a:rPr lang="en-US" sz="1350" b="1" dirty="0">
+                <a:solidFill>
+                  <a:srgbClr val="0F172A"/>
+                </a:solidFill>
+                <a:latin typeface="Segoe UI" pitchFamily="34" charset="0"/>
+                <a:ea typeface="Segoe UI" pitchFamily="34" charset="-122"/>
+                <a:cs typeface="Segoe UI" pitchFamily="34" charset="-120"/>
+              </a:rPr>
+              <a:t>Bước 2 - Admin trường (BGH): đăng nhập → /school/users → '+ Thêm giáo viên'</a:t>
             </a:r>
             <a:endParaRPr lang="en-US" sz="1350" dirty="0"/>
           </a:p>
@@ -3848,13 +4000,55 @@
             <a:r>
               <a:rPr lang="en-US" sz="1350" dirty="0">
                 <a:solidFill>
-                  <a:srgbClr val="0F766E"/>
-                </a:solidFill>
-                <a:latin typeface="Segoe UI" pitchFamily="34" charset="0"/>
-                <a:ea typeface="Segoe UI" pitchFamily="34" charset="-122"/>
-                <a:cs typeface="Segoe UI" pitchFamily="34" charset="-120"/>
-              </a:rPr>
-              <a:t>Phân quyền chức năng + dữ liệu tới item-level ACL - admin trường tự quản, không cần IT</a:t>
+                  <a:srgbClr val="0F172A"/>
+                </a:solidFill>
+                <a:latin typeface="Segoe UI" pitchFamily="34" charset="0"/>
+                <a:ea typeface="Segoe UI" pitchFamily="34" charset="-122"/>
+                <a:cs typeface="Segoe UI" pitchFamily="34" charset="-120"/>
+              </a:rPr>
+              <a:t>[object Object]</a:t>
+            </a:r>
+            <a:endParaRPr lang="en-US" sz="1350" dirty="0"/>
+          </a:p>
+          <a:p>
+            <a:pPr marL="381000" indent="-381000">
+              <a:spcAft>
+                <a:spcPts val="800"/>
+              </a:spcAft>
+              <a:buSzPct val="100000"/>
+              <a:buChar char="–"/>
+            </a:pPr>
+            <a:r>
+              <a:rPr lang="en-US" sz="1200" dirty="0">
+                <a:solidFill>
+                  <a:srgbClr val="475569"/>
+                </a:solidFill>
+                <a:latin typeface="Segoe UI" pitchFamily="34" charset="0"/>
+                <a:ea typeface="Segoe UI" pitchFamily="34" charset="-122"/>
+                <a:cs typeface="Segoe UI" pitchFamily="34" charset="-120"/>
+              </a:rPr>
+              <a:t>Tự tạo tài khoản GV/GVCN/tổ trưởng/kế toán trong phạm vi trường mình - không cần đội kỹ thuật</a:t>
+            </a:r>
+            <a:endParaRPr lang="en-US" sz="1350" dirty="0"/>
+          </a:p>
+          <a:p>
+            <a:pPr marL="381000" indent="-381000">
+              <a:spcAft>
+                <a:spcPts val="800"/>
+              </a:spcAft>
+              <a:buSzPct val="100000"/>
+              <a:buChar char="–"/>
+            </a:pPr>
+            <a:r>
+              <a:rPr lang="en-US" sz="1200" dirty="0">
+                <a:solidFill>
+                  <a:srgbClr val="475569"/>
+                </a:solidFill>
+                <a:latin typeface="Segoe UI" pitchFamily="34" charset="0"/>
+                <a:ea typeface="Segoe UI" pitchFamily="34" charset="-122"/>
+                <a:cs typeface="Segoe UI" pitchFamily="34" charset="-120"/>
+              </a:rPr>
+              <a:t>Import danh sách HS qua Excel tại /records/upload (mã HS, CCCD, họ tên, ngày sinh, giới tính)</a:t>
             </a:r>
             <a:endParaRPr lang="en-US" sz="1350" dirty="0"/>
           </a:p>
@@ -3867,15 +4061,15 @@
               <a:buChar char="•"/>
             </a:pPr>
             <a:r>
-              <a:rPr lang="en-US" sz="1350" dirty="0">
-                <a:solidFill>
-                  <a:srgbClr val="0F766E"/>
-                </a:solidFill>
-                <a:latin typeface="Segoe UI" pitchFamily="34" charset="0"/>
-                <a:ea typeface="Segoe UI" pitchFamily="34" charset="-122"/>
-                <a:cs typeface="Segoe UI" pitchFamily="34" charset="-120"/>
-              </a:rPr>
-              <a:t>Multi-tenant RLS nghiêm ngặt + DPIA theo Luật 91/2025 - sẵn sàng pilot liên trường</a:t>
+              <a:rPr lang="en-US" sz="1350" b="1" dirty="0">
+                <a:solidFill>
+                  <a:srgbClr val="0F172A"/>
+                </a:solidFill>
+                <a:latin typeface="Segoe UI" pitchFamily="34" charset="0"/>
+                <a:ea typeface="Segoe UI" pitchFamily="34" charset="-122"/>
+                <a:cs typeface="Segoe UI" pitchFamily="34" charset="-120"/>
+              </a:rPr>
+              <a:t>Bước 3 - GVCN: /register/roster liên kết PH - HS và cấp tài khoản cổng PH</a:t>
             </a:r>
             <a:endParaRPr lang="en-US" sz="1350" dirty="0"/>
           </a:p>
@@ -3888,17 +4082,119 @@
               <a:buChar char="•"/>
             </a:pPr>
             <a:r>
+              <a:rPr lang="en-US" sz="1350" b="1" dirty="0">
+                <a:solidFill>
+                  <a:srgbClr val="0F172A"/>
+                </a:solidFill>
+                <a:latin typeface="Segoe UI" pitchFamily="34" charset="0"/>
+                <a:ea typeface="Segoe UI" pitchFamily="34" charset="-122"/>
+                <a:cs typeface="Segoe UI" pitchFamily="34" charset="-120"/>
+              </a:rPr>
+              <a:t>Giám sát - Sở GD: /dept/usage</a:t>
+            </a:r>
+            <a:endParaRPr lang="en-US" sz="1350" dirty="0"/>
+          </a:p>
+          <a:p>
+            <a:pPr marL="177800" indent="-177800">
+              <a:spcAft>
+                <a:spcPts val="800"/>
+              </a:spcAft>
+              <a:buSzPct val="100000"/>
+              <a:buChar char="•"/>
+            </a:pPr>
+            <a:r>
               <a:rPr lang="en-US" sz="1350" dirty="0">
                 <a:solidFill>
+                  <a:srgbClr val="0F172A"/>
+                </a:solidFill>
+                <a:latin typeface="Segoe UI" pitchFamily="34" charset="0"/>
+                <a:ea typeface="Segoe UI" pitchFamily="34" charset="-122"/>
+                <a:cs typeface="Segoe UI" pitchFamily="34" charset="-120"/>
+              </a:rPr>
+              <a:t>[object Object]</a:t>
+            </a:r>
+            <a:endParaRPr lang="en-US" sz="1350" dirty="0"/>
+          </a:p>
+          <a:p>
+            <a:pPr marL="381000" indent="-381000">
+              <a:spcAft>
+                <a:spcPts val="800"/>
+              </a:spcAft>
+              <a:buSzPct val="100000"/>
+              <a:buChar char="–"/>
+            </a:pPr>
+            <a:r>
+              <a:rPr lang="en-US" sz="1200" dirty="0">
+                <a:solidFill>
+                  <a:srgbClr val="475569"/>
+                </a:solidFill>
+                <a:latin typeface="Segoe UI" pitchFamily="34" charset="0"/>
+                <a:ea typeface="Segoe UI" pitchFamily="34" charset="-122"/>
+                <a:cs typeface="Segoe UI" pitchFamily="34" charset="-120"/>
+              </a:rPr>
+              <a:t>Bảng theo trường: tổng user, active 24h, active 7d, lần đăng nhập gần nhất</a:t>
+            </a:r>
+            <a:endParaRPr lang="en-US" sz="1350" dirty="0"/>
+          </a:p>
+          <a:p>
+            <a:pPr marL="381000" indent="-381000">
+              <a:spcAft>
+                <a:spcPts val="800"/>
+              </a:spcAft>
+              <a:buSzPct val="100000"/>
+              <a:buChar char="–"/>
+            </a:pPr>
+            <a:r>
+              <a:rPr lang="en-US" sz="1200" dirty="0">
+                <a:solidFill>
+                  <a:srgbClr val="475569"/>
+                </a:solidFill>
+                <a:latin typeface="Segoe UI" pitchFamily="34" charset="0"/>
+                <a:ea typeface="Segoe UI" pitchFamily="34" charset="-122"/>
+                <a:cs typeface="Segoe UI" pitchFamily="34" charset="-120"/>
+              </a:rPr>
+              <a:t>Bảng user: tên, vai trò, trường, last sign-in - đo mức độ dùng của từng trường pilot</a:t>
+            </a:r>
+            <a:endParaRPr lang="en-US" sz="1350" dirty="0"/>
+          </a:p>
+        </p:txBody>
+      </p:sp>
+      <p:sp>
+        <p:nvSpPr>
+          <p:cNvPr id="6" name="Text 4"/>
+          <p:cNvSpPr/>
+          <p:nvPr/>
+        </p:nvSpPr>
+        <p:spPr>
+          <a:xfrm>
+            <a:off x="640080" y="6263640"/>
+            <a:ext cx="10972800" cy="457200"/>
+          </a:xfrm>
+          <a:prstGeom prst="rect">
+            <a:avLst/>
+          </a:prstGeom>
+          <a:noFill/>
+          <a:ln/>
+        </p:spPr>
+        <p:txBody>
+          <a:bodyPr wrap="square" rtlCol="0" anchor="ctr"/>
+          <a:lstStyle/>
+          <a:p>
+            <a:pPr indent="0" marL="0">
+              <a:buNone/>
+            </a:pPr>
+            <a:r>
+              <a:rPr lang="en-US" sz="1050" i="1" dirty="0">
+                <a:solidFill>
                   <a:srgbClr val="0F766E"/>
                 </a:solidFill>
                 <a:latin typeface="Segoe UI" pitchFamily="34" charset="0"/>
                 <a:ea typeface="Segoe UI" pitchFamily="34" charset="-122"/>
                 <a:cs typeface="Segoe UI" pitchFamily="34" charset="-120"/>
               </a:rPr>
-              <a:t>AI provider linh hoạt (Gemini/OpenAI/Anthropic qua env) + fallback engine + rule-based - không chết khi hết quota</a:t>
-            </a:r>
-            <a:endParaRPr lang="en-US" sz="1350" dirty="0"/>
+              <a:t>Demo gate 15/10: trường tự đăng nhập dùng thử - quy trình trên là toàn bộ onboarding.</a:t>
+            </a:r>
+            <a:endParaRPr lang="en-US" sz="1050" dirty="0"/>
           </a:p>
         </p:txBody>
       </p:sp>
@@ -3960,7 +4256,7 @@
                 <a:ea typeface="Segoe UI" pitchFamily="34" charset="-122"/>
                 <a:cs typeface="Segoe UI" pitchFamily="34" charset="-120"/>
               </a:rPr>
-              <a:t>CHECKLIST TEST CHUYÊN GIA</a:t>
+              <a:t>ĐIỂM NỔI BẬT</a:t>
             </a:r>
             <a:endParaRPr lang="en-US" sz="1100" dirty="0"/>
           </a:p>
@@ -3999,7 +4295,7 @@
                 <a:ea typeface="Segoe UI" pitchFamily="34" charset="-122"/>
                 <a:cs typeface="Segoe UI" pitchFamily="34" charset="-120"/>
               </a:rPr>
-              <a:t>Các kịch bản ưu tiên rà soát</a:t>
+              <a:t>Khác biệt so với nền tảng thông thường</a:t>
             </a:r>
             <a:endParaRPr lang="en-US" sz="2600" dirty="0"/>
           </a:p>
@@ -4057,15 +4353,15 @@
               <a:buChar char="•"/>
             </a:pPr>
             <a:r>
-              <a:rPr lang="en-US" sz="1350" b="1" dirty="0">
-                <a:solidFill>
-                  <a:srgbClr val="0F172A"/>
-                </a:solidFill>
-                <a:latin typeface="Segoe UI" pitchFamily="34" charset="0"/>
-                <a:ea typeface="Segoe UI" pitchFamily="34" charset="-122"/>
-                <a:cs typeface="Segoe UI" pitchFamily="34" charset="-120"/>
-              </a:rPr>
-              <a:t>NỘI DUNG: đọc kỹ câu hỏi bank (đáp án đúng? phù hợp lứa tuổi? ngôn ngữ tiểu học?); KHBĐ có đúng flow sư phạm? YCCĐ gán khớp?</a:t>
+              <a:rPr lang="en-US" sz="1350" dirty="0">
+                <a:solidFill>
+                  <a:srgbClr val="0F766E"/>
+                </a:solidFill>
+                <a:latin typeface="Segoe UI" pitchFamily="34" charset="0"/>
+                <a:ea typeface="Segoe UI" pitchFamily="34" charset="-122"/>
+                <a:cs typeface="Segoe UI" pitchFamily="34" charset="-120"/>
+              </a:rPr>
+              <a:t>Bám quy định thật: YCCĐ CTGDPT 2018 chi tiết đến strand; TT22/2021 (HK1/HK2/năm tách, không KT giấy lớp 1-3 giữa kì); TT27/2025</a:t>
             </a:r>
             <a:endParaRPr lang="en-US" sz="1350" dirty="0"/>
           </a:p>
@@ -4078,15 +4374,15 @@
               <a:buChar char="•"/>
             </a:pPr>
             <a:r>
-              <a:rPr lang="en-US" sz="1350" b="1" dirty="0">
-                <a:solidFill>
-                  <a:srgbClr val="0F172A"/>
-                </a:solidFill>
-                <a:latin typeface="Segoe UI" pitchFamily="34" charset="0"/>
-                <a:ea typeface="Segoe UI" pitchFamily="34" charset="-122"/>
-                <a:cs typeface="Segoe UI" pitchFamily="34" charset="-120"/>
-              </a:rPr>
-              <a:t>ĐỀ THI: sinh đề GK1 Toán 4-5 + TV 4-5 → check ma trận, điểm, đáp án, hình vẽ, định dạng in</a:t>
+              <a:rPr lang="en-US" sz="1350" dirty="0">
+                <a:solidFill>
+                  <a:srgbClr val="0F766E"/>
+                </a:solidFill>
+                <a:latin typeface="Segoe UI" pitchFamily="34" charset="0"/>
+                <a:ea typeface="Segoe UI" pitchFamily="34" charset="-122"/>
+                <a:cs typeface="Segoe UI" pitchFamily="34" charset="-120"/>
+              </a:rPr>
+              <a:t>Ngân hàng trường + duyệt 2 lớp + audit trail - kiểm soát chất lượng đề như trường thật vận hành</a:t>
             </a:r>
             <a:endParaRPr lang="en-US" sz="1350" dirty="0"/>
           </a:p>
@@ -4099,15 +4395,15 @@
               <a:buChar char="•"/>
             </a:pPr>
             <a:r>
-              <a:rPr lang="en-US" sz="1350" b="1" dirty="0">
-                <a:solidFill>
-                  <a:srgbClr val="0F172A"/>
-                </a:solidFill>
-                <a:latin typeface="Segoe UI" pitchFamily="34" charset="0"/>
-                <a:ea typeface="Segoe UI" pitchFamily="34" charset="-122"/>
-                <a:cs typeface="Segoe UI" pitchFamily="34" charset="-120"/>
-              </a:rPr>
-              <a:t>WORKFLOW: đóng góp → duyệt tổ → duyệt BGH → notification đúng người</a:t>
+              <a:rPr lang="en-US" sz="1350" dirty="0">
+                <a:solidFill>
+                  <a:srgbClr val="0F766E"/>
+                </a:solidFill>
+                <a:latin typeface="Segoe UI" pitchFamily="34" charset="0"/>
+                <a:ea typeface="Segoe UI" pitchFamily="34" charset="-122"/>
+                <a:cs typeface="Segoe UI" pitchFamily="34" charset="-120"/>
+              </a:rPr>
+              <a:t>Hình học deterministic (không AI ảo) + xuất Word Equation native - in thi thật dùng được ngay</a:t>
             </a:r>
             <a:endParaRPr lang="en-US" sz="1350" dirty="0"/>
           </a:p>
@@ -4120,15 +4416,15 @@
               <a:buChar char="•"/>
             </a:pPr>
             <a:r>
-              <a:rPr lang="en-US" sz="1350" b="1" dirty="0">
-                <a:solidFill>
-                  <a:srgbClr val="0F172A"/>
-                </a:solidFill>
-                <a:latin typeface="Segoe UI" pitchFamily="34" charset="0"/>
-                <a:ea typeface="Segoe UI" pitchFamily="34" charset="-122"/>
-                <a:cs typeface="Segoe UI" pitchFamily="34" charset="-120"/>
-              </a:rPr>
-              <a:t>PHÂN QUYỀN: gvbm không duyệt được; tổ trưởng chỉ thấy môn tổ; phụ huynh không vào được bank</a:t>
+              <a:rPr lang="en-US" sz="1350" dirty="0">
+                <a:solidFill>
+                  <a:srgbClr val="0F766E"/>
+                </a:solidFill>
+                <a:latin typeface="Segoe UI" pitchFamily="34" charset="0"/>
+                <a:ea typeface="Segoe UI" pitchFamily="34" charset="-122"/>
+                <a:cs typeface="Segoe UI" pitchFamily="34" charset="-120"/>
+              </a:rPr>
+              <a:t>Phân quyền chức năng + dữ liệu tới item-level ACL - admin trường tự quản, không cần IT</a:t>
             </a:r>
             <a:endParaRPr lang="en-US" sz="1350" dirty="0"/>
           </a:p>
@@ -4141,15 +4437,36 @@
               <a:buChar char="•"/>
             </a:pPr>
             <a:r>
-              <a:rPr lang="en-US" sz="1350" b="1" dirty="0">
-                <a:solidFill>
-                  <a:srgbClr val="0F172A"/>
-                </a:solidFill>
-                <a:latin typeface="Segoe UI" pitchFamily="34" charset="0"/>
-                <a:ea typeface="Segoe UI" pitchFamily="34" charset="-122"/>
-                <a:cs typeface="Segoe UI" pitchFamily="34" charset="-120"/>
-              </a:rPr>
-              <a:t>EDGE CASES: câu nói 'như hình' không hình → bị chặn; import Excel sai format → báo lỗi rõ; câu trùng stem → cảnh báo dedupe</a:t>
+              <a:rPr lang="en-US" sz="1350" dirty="0">
+                <a:solidFill>
+                  <a:srgbClr val="0F766E"/>
+                </a:solidFill>
+                <a:latin typeface="Segoe UI" pitchFamily="34" charset="0"/>
+                <a:ea typeface="Segoe UI" pitchFamily="34" charset="-122"/>
+                <a:cs typeface="Segoe UI" pitchFamily="34" charset="-120"/>
+              </a:rPr>
+              <a:t>Multi-tenant RLS nghiêm ngặt + DPIA theo Luật 91/2025 - sẵn sàng pilot liên trường</a:t>
+            </a:r>
+            <a:endParaRPr lang="en-US" sz="1350" dirty="0"/>
+          </a:p>
+          <a:p>
+            <a:pPr marL="177800" indent="-177800">
+              <a:spcAft>
+                <a:spcPts val="800"/>
+              </a:spcAft>
+              <a:buSzPct val="100000"/>
+              <a:buChar char="•"/>
+            </a:pPr>
+            <a:r>
+              <a:rPr lang="en-US" sz="1350" dirty="0">
+                <a:solidFill>
+                  <a:srgbClr val="0F766E"/>
+                </a:solidFill>
+                <a:latin typeface="Segoe UI" pitchFamily="34" charset="0"/>
+                <a:ea typeface="Segoe UI" pitchFamily="34" charset="-122"/>
+                <a:cs typeface="Segoe UI" pitchFamily="34" charset="-120"/>
+              </a:rPr>
+              <a:t>AI provider linh hoạt (Gemini/OpenAI/Anthropic qua env) + fallback engine + rule-based - không chết khi hết quota</a:t>
             </a:r>
             <a:endParaRPr lang="en-US" sz="1350" dirty="0"/>
           </a:p>
@@ -4166,6 +4483,259 @@
 <file path=ppt/slides/slide16.xml><?xml version="1.0" encoding="utf-8"?>
 <p:sld xmlns:a="http://schemas.openxmlformats.org/drawingml/2006/main" xmlns:r="http://schemas.openxmlformats.org/officeDocument/2006/relationships" xmlns:p="http://schemas.openxmlformats.org/presentationml/2006/main">
   <p:cSld name="Slide 16">
+    <p:spTree>
+      <p:nvGrpSpPr>
+        <p:cNvPr id="1" name=""/>
+        <p:cNvGrpSpPr/>
+        <p:nvPr/>
+      </p:nvGrpSpPr>
+      <p:grpSpPr>
+        <a:xfrm>
+          <a:off x="0" y="0"/>
+          <a:ext cx="0" cy="0"/>
+          <a:chOff x="0" y="0"/>
+          <a:chExt cx="0" cy="0"/>
+        </a:xfrm>
+      </p:grpSpPr>
+      <p:sp>
+        <p:nvSpPr>
+          <p:cNvPr id="2" name="Text 0"/>
+          <p:cNvSpPr/>
+          <p:nvPr/>
+        </p:nvSpPr>
+        <p:spPr>
+          <a:xfrm>
+            <a:off x="502920" y="256032"/>
+            <a:ext cx="10972800" cy="274320"/>
+          </a:xfrm>
+          <a:prstGeom prst="rect">
+            <a:avLst/>
+          </a:prstGeom>
+          <a:noFill/>
+          <a:ln/>
+        </p:spPr>
+        <p:txBody>
+          <a:bodyPr wrap="square" rtlCol="0" anchor="ctr"/>
+          <a:lstStyle/>
+          <a:p>
+            <a:pPr indent="0" marL="0">
+              <a:buNone/>
+            </a:pPr>
+            <a:r>
+              <a:rPr lang="en-US" sz="1100" b="1" dirty="0">
+                <a:solidFill>
+                  <a:srgbClr val="0F766E"/>
+                </a:solidFill>
+                <a:latin typeface="Segoe UI" pitchFamily="34" charset="0"/>
+                <a:ea typeface="Segoe UI" pitchFamily="34" charset="-122"/>
+                <a:cs typeface="Segoe UI" pitchFamily="34" charset="-120"/>
+              </a:rPr>
+              <a:t>CHECKLIST TEST CHUYÊN GIA</a:t>
+            </a:r>
+            <a:endParaRPr lang="en-US" sz="1100" dirty="0"/>
+          </a:p>
+        </p:txBody>
+      </p:sp>
+      <p:sp>
+        <p:nvSpPr>
+          <p:cNvPr id="3" name="Text 1"/>
+          <p:cNvSpPr/>
+          <p:nvPr/>
+        </p:nvSpPr>
+        <p:spPr>
+          <a:xfrm>
+            <a:off x="502920" y="502920"/>
+            <a:ext cx="11155680" cy="640080"/>
+          </a:xfrm>
+          <a:prstGeom prst="rect">
+            <a:avLst/>
+          </a:prstGeom>
+          <a:noFill/>
+          <a:ln/>
+        </p:spPr>
+        <p:txBody>
+          <a:bodyPr wrap="square" rtlCol="0" anchor="ctr"/>
+          <a:lstStyle/>
+          <a:p>
+            <a:pPr indent="0" marL="0">
+              <a:buNone/>
+            </a:pPr>
+            <a:r>
+              <a:rPr lang="en-US" sz="2600" b="1" dirty="0">
+                <a:solidFill>
+                  <a:srgbClr val="0F172A"/>
+                </a:solidFill>
+                <a:latin typeface="Segoe UI" pitchFamily="34" charset="0"/>
+                <a:ea typeface="Segoe UI" pitchFamily="34" charset="-122"/>
+                <a:cs typeface="Segoe UI" pitchFamily="34" charset="-120"/>
+              </a:rPr>
+              <a:t>Các kịch bản ưu tiên rà soát</a:t>
+            </a:r>
+            <a:endParaRPr lang="en-US" sz="2600" dirty="0"/>
+          </a:p>
+        </p:txBody>
+      </p:sp>
+      <p:sp>
+        <p:nvSpPr>
+          <p:cNvPr id="4" name="Shape 2"/>
+          <p:cNvSpPr/>
+          <p:nvPr/>
+        </p:nvSpPr>
+        <p:spPr>
+          <a:xfrm>
+            <a:off x="502920" y="1572768"/>
+            <a:ext cx="11155680" cy="0"/>
+          </a:xfrm>
+          <a:prstGeom prst="line">
+            <a:avLst/>
+          </a:prstGeom>
+          <a:noFill/>
+          <a:ln w="12700">
+            <a:solidFill>
+              <a:srgbClr val="E2E8F0"/>
+            </a:solidFill>
+            <a:prstDash val="solid"/>
+          </a:ln>
+        </p:spPr>
+      </p:sp>
+      <p:sp>
+        <p:nvSpPr>
+          <p:cNvPr id="5" name="Text 3"/>
+          <p:cNvSpPr/>
+          <p:nvPr/>
+        </p:nvSpPr>
+        <p:spPr>
+          <a:xfrm>
+            <a:off x="640080" y="1783080"/>
+            <a:ext cx="10972800" cy="4572000"/>
+          </a:xfrm>
+          <a:prstGeom prst="rect">
+            <a:avLst/>
+          </a:prstGeom>
+          <a:noFill/>
+          <a:ln/>
+        </p:spPr>
+        <p:txBody>
+          <a:bodyPr wrap="square" rtlCol="0" anchor="t"/>
+          <a:lstStyle/>
+          <a:p>
+            <a:pPr marL="177800" indent="-177800">
+              <a:spcAft>
+                <a:spcPts val="800"/>
+              </a:spcAft>
+              <a:buSzPct val="100000"/>
+              <a:buChar char="•"/>
+            </a:pPr>
+            <a:r>
+              <a:rPr lang="en-US" sz="1350" b="1" dirty="0">
+                <a:solidFill>
+                  <a:srgbClr val="0F172A"/>
+                </a:solidFill>
+                <a:latin typeface="Segoe UI" pitchFamily="34" charset="0"/>
+                <a:ea typeface="Segoe UI" pitchFamily="34" charset="-122"/>
+                <a:cs typeface="Segoe UI" pitchFamily="34" charset="-120"/>
+              </a:rPr>
+              <a:t>NỘI DUNG: đọc kỹ câu hỏi bank (đáp án đúng? phù hợp lứa tuổi? ngôn ngữ tiểu học?); KHBĐ có đúng flow sư phạm? YCCĐ gán khớp?</a:t>
+            </a:r>
+            <a:endParaRPr lang="en-US" sz="1350" dirty="0"/>
+          </a:p>
+          <a:p>
+            <a:pPr marL="177800" indent="-177800">
+              <a:spcAft>
+                <a:spcPts val="800"/>
+              </a:spcAft>
+              <a:buSzPct val="100000"/>
+              <a:buChar char="•"/>
+            </a:pPr>
+            <a:r>
+              <a:rPr lang="en-US" sz="1350" b="1" dirty="0">
+                <a:solidFill>
+                  <a:srgbClr val="0F172A"/>
+                </a:solidFill>
+                <a:latin typeface="Segoe UI" pitchFamily="34" charset="0"/>
+                <a:ea typeface="Segoe UI" pitchFamily="34" charset="-122"/>
+                <a:cs typeface="Segoe UI" pitchFamily="34" charset="-120"/>
+              </a:rPr>
+              <a:t>ĐỀ THI: sinh đề GK1 Toán 4-5 + TV 4-5 → check ma trận, điểm, đáp án, hình vẽ, định dạng in</a:t>
+            </a:r>
+            <a:endParaRPr lang="en-US" sz="1350" dirty="0"/>
+          </a:p>
+          <a:p>
+            <a:pPr marL="177800" indent="-177800">
+              <a:spcAft>
+                <a:spcPts val="800"/>
+              </a:spcAft>
+              <a:buSzPct val="100000"/>
+              <a:buChar char="•"/>
+            </a:pPr>
+            <a:r>
+              <a:rPr lang="en-US" sz="1350" b="1" dirty="0">
+                <a:solidFill>
+                  <a:srgbClr val="0F172A"/>
+                </a:solidFill>
+                <a:latin typeface="Segoe UI" pitchFamily="34" charset="0"/>
+                <a:ea typeface="Segoe UI" pitchFamily="34" charset="-122"/>
+                <a:cs typeface="Segoe UI" pitchFamily="34" charset="-120"/>
+              </a:rPr>
+              <a:t>WORKFLOW: đóng góp → duyệt tổ → duyệt BGH → notification đúng người</a:t>
+            </a:r>
+            <a:endParaRPr lang="en-US" sz="1350" dirty="0"/>
+          </a:p>
+          <a:p>
+            <a:pPr marL="177800" indent="-177800">
+              <a:spcAft>
+                <a:spcPts val="800"/>
+              </a:spcAft>
+              <a:buSzPct val="100000"/>
+              <a:buChar char="•"/>
+            </a:pPr>
+            <a:r>
+              <a:rPr lang="en-US" sz="1350" b="1" dirty="0">
+                <a:solidFill>
+                  <a:srgbClr val="0F172A"/>
+                </a:solidFill>
+                <a:latin typeface="Segoe UI" pitchFamily="34" charset="0"/>
+                <a:ea typeface="Segoe UI" pitchFamily="34" charset="-122"/>
+                <a:cs typeface="Segoe UI" pitchFamily="34" charset="-120"/>
+              </a:rPr>
+              <a:t>PHÂN QUYỀN: gvbm không duyệt được; tổ trưởng chỉ thấy môn tổ; phụ huynh không vào được bank</a:t>
+            </a:r>
+            <a:endParaRPr lang="en-US" sz="1350" dirty="0"/>
+          </a:p>
+          <a:p>
+            <a:pPr marL="177800" indent="-177800">
+              <a:spcAft>
+                <a:spcPts val="800"/>
+              </a:spcAft>
+              <a:buSzPct val="100000"/>
+              <a:buChar char="•"/>
+            </a:pPr>
+            <a:r>
+              <a:rPr lang="en-US" sz="1350" b="1" dirty="0">
+                <a:solidFill>
+                  <a:srgbClr val="0F172A"/>
+                </a:solidFill>
+                <a:latin typeface="Segoe UI" pitchFamily="34" charset="0"/>
+                <a:ea typeface="Segoe UI" pitchFamily="34" charset="-122"/>
+                <a:cs typeface="Segoe UI" pitchFamily="34" charset="-120"/>
+              </a:rPr>
+              <a:t>EDGE CASES: câu nói 'như hình' không hình → bị chặn; import Excel sai format → báo lỗi rõ; câu trùng stem → cảnh báo dedupe</a:t>
+            </a:r>
+            <a:endParaRPr lang="en-US" sz="1350" dirty="0"/>
+          </a:p>
+        </p:txBody>
+      </p:sp>
+    </p:spTree>
+  </p:cSld>
+  <p:clrMapOvr>
+    <a:masterClrMapping/>
+  </p:clrMapOvr>
+</p:sld>
+</file>
+
+<file path=ppt/slides/slide17.xml><?xml version="1.0" encoding="utf-8"?>
+<p:sld xmlns:a="http://schemas.openxmlformats.org/drawingml/2006/main" xmlns:r="http://schemas.openxmlformats.org/officeDocument/2006/relationships" xmlns:p="http://schemas.openxmlformats.org/presentationml/2006/main">
+  <p:cSld name="Slide 17">
     <p:spTree>
       <p:nvGrpSpPr>
         <p:cNvPr id="1" name=""/>
@@ -6874,6 +7444,280 @@
                   </a:tcPr>
                 </a:tc>
               </a:tr>
+              <a:tr h="384048">
+                <a:tc>
+                  <a:txBody>
+                    <a:bodyPr/>
+                    <a:lstStyle/>
+                    <a:p>
+                      <a:pPr indent="0" marL="0">
+                        <a:buNone/>
+                      </a:pPr>
+                      <a:r>
+                        <a:rPr lang="en-US" sz="1100" dirty="0">
+                          <a:solidFill>
+                            <a:srgbClr val="0F172A"/>
+                          </a:solidFill>
+                          <a:latin typeface="Segoe UI" pitchFamily="34" charset="0"/>
+                          <a:ea typeface="Segoe UI" pitchFamily="34" charset="-122"/>
+                          <a:cs typeface="Segoe UI" pitchFamily="34" charset="-120"/>
+                        </a:rPr>
+                        <a:t>Sở GD&amp;ĐT (demo)</a:t>
+                      </a:r>
+                      <a:endParaRPr lang="en-US" sz="1100" dirty="0">
+                        <a:latin typeface="Segoe UI" charset="0"/>
+                        <a:ea typeface="Segoe UI" charset="0"/>
+                        <a:cs typeface="Segoe UI" charset="0"/>
+                      </a:endParaRPr>
+                    </a:p>
+                  </a:txBody>
+                  <a:tcPr marL="73152" marR="73152" marT="73152" marB="73152" anchor="ctr">
+                    <a:lnL w="9525" cap="flat" cmpd="sng" algn="ctr">
+                      <a:solidFill>
+                        <a:srgbClr val="E2E8F0"/>
+                      </a:solidFill>
+                      <a:prstDash val="solid"/>
+                      <a:round/>
+                      <a:headEnd type="none" w="med" len="med"/>
+                      <a:tailEnd type="none" w="med" len="med"/>
+                    </a:lnL>
+                    <a:lnR w="9525" cap="flat" cmpd="sng" algn="ctr">
+                      <a:solidFill>
+                        <a:srgbClr val="E2E8F0"/>
+                      </a:solidFill>
+                      <a:prstDash val="solid"/>
+                      <a:round/>
+                      <a:headEnd type="none" w="med" len="med"/>
+                      <a:tailEnd type="none" w="med" len="med"/>
+                    </a:lnR>
+                    <a:lnT w="9525" cap="flat" cmpd="sng" algn="ctr">
+                      <a:solidFill>
+                        <a:srgbClr val="E2E8F0"/>
+                      </a:solidFill>
+                      <a:prstDash val="solid"/>
+                      <a:round/>
+                      <a:headEnd type="none" w="med" len="med"/>
+                      <a:tailEnd type="none" w="med" len="med"/>
+                    </a:lnT>
+                    <a:lnB w="9525" cap="flat" cmpd="sng" algn="ctr">
+                      <a:solidFill>
+                        <a:srgbClr val="E2E8F0"/>
+                      </a:solidFill>
+                      <a:prstDash val="solid"/>
+                      <a:round/>
+                      <a:headEnd type="none" w="med" len="med"/>
+                      <a:tailEnd type="none" w="med" len="med"/>
+                    </a:lnB>
+                    <a:solidFill>
+                      <a:srgbClr val="FFFFFF"/>
+                    </a:solidFill>
+                  </a:tcPr>
+                </a:tc>
+                <a:tc>
+                  <a:txBody>
+                    <a:bodyPr/>
+                    <a:lstStyle/>
+                    <a:p>
+                      <a:pPr indent="0" marL="0">
+                        <a:buNone/>
+                      </a:pPr>
+                      <a:r>
+                        <a:rPr lang="en-US" sz="1100" dirty="0">
+                          <a:solidFill>
+                            <a:srgbClr val="0F172A"/>
+                          </a:solidFill>
+                          <a:latin typeface="Segoe UI" pitchFamily="34" charset="0"/>
+                          <a:ea typeface="Segoe UI" pitchFamily="34" charset="-122"/>
+                          <a:cs typeface="Segoe UI" pitchFamily="34" charset="-120"/>
+                        </a:rPr>
+                        <a:t>sogd@demo.scn</a:t>
+                      </a:r>
+                      <a:endParaRPr lang="en-US" sz="1100" dirty="0">
+                        <a:latin typeface="Segoe UI" charset="0"/>
+                        <a:ea typeface="Segoe UI" charset="0"/>
+                        <a:cs typeface="Segoe UI" charset="0"/>
+                      </a:endParaRPr>
+                    </a:p>
+                  </a:txBody>
+                  <a:tcPr marL="73152" marR="73152" marT="73152" marB="73152" anchor="ctr">
+                    <a:lnL w="9525" cap="flat" cmpd="sng" algn="ctr">
+                      <a:solidFill>
+                        <a:srgbClr val="E2E8F0"/>
+                      </a:solidFill>
+                      <a:prstDash val="solid"/>
+                      <a:round/>
+                      <a:headEnd type="none" w="med" len="med"/>
+                      <a:tailEnd type="none" w="med" len="med"/>
+                    </a:lnL>
+                    <a:lnR w="9525" cap="flat" cmpd="sng" algn="ctr">
+                      <a:solidFill>
+                        <a:srgbClr val="E2E8F0"/>
+                      </a:solidFill>
+                      <a:prstDash val="solid"/>
+                      <a:round/>
+                      <a:headEnd type="none" w="med" len="med"/>
+                      <a:tailEnd type="none" w="med" len="med"/>
+                    </a:lnR>
+                    <a:lnT w="9525" cap="flat" cmpd="sng" algn="ctr">
+                      <a:solidFill>
+                        <a:srgbClr val="E2E8F0"/>
+                      </a:solidFill>
+                      <a:prstDash val="solid"/>
+                      <a:round/>
+                      <a:headEnd type="none" w="med" len="med"/>
+                      <a:tailEnd type="none" w="med" len="med"/>
+                    </a:lnT>
+                    <a:lnB w="9525" cap="flat" cmpd="sng" algn="ctr">
+                      <a:solidFill>
+                        <a:srgbClr val="E2E8F0"/>
+                      </a:solidFill>
+                      <a:prstDash val="solid"/>
+                      <a:round/>
+                      <a:headEnd type="none" w="med" len="med"/>
+                      <a:tailEnd type="none" w="med" len="med"/>
+                    </a:lnB>
+                    <a:solidFill>
+                      <a:srgbClr val="FFFFFF"/>
+                    </a:solidFill>
+                  </a:tcPr>
+                </a:tc>
+                <a:tc>
+                  <a:txBody>
+                    <a:bodyPr/>
+                    <a:lstStyle/>
+                    <a:p>
+                      <a:pPr indent="0" marL="0">
+                        <a:buNone/>
+                      </a:pPr>
+                      <a:r>
+                        <a:rPr lang="en-US" sz="1100" dirty="0">
+                          <a:solidFill>
+                            <a:srgbClr val="0F172A"/>
+                          </a:solidFill>
+                          <a:latin typeface="Segoe UI" pitchFamily="34" charset="0"/>
+                          <a:ea typeface="Segoe UI" pitchFamily="34" charset="-122"/>
+                          <a:cs typeface="Segoe UI" pitchFamily="34" charset="-120"/>
+                        </a:rPr>
+                        <a:t>demo1234</a:t>
+                      </a:r>
+                      <a:endParaRPr lang="en-US" sz="1100" dirty="0">
+                        <a:latin typeface="Segoe UI" charset="0"/>
+                        <a:ea typeface="Segoe UI" charset="0"/>
+                        <a:cs typeface="Segoe UI" charset="0"/>
+                      </a:endParaRPr>
+                    </a:p>
+                  </a:txBody>
+                  <a:tcPr marL="73152" marR="73152" marT="73152" marB="73152" anchor="ctr">
+                    <a:lnL w="9525" cap="flat" cmpd="sng" algn="ctr">
+                      <a:solidFill>
+                        <a:srgbClr val="E2E8F0"/>
+                      </a:solidFill>
+                      <a:prstDash val="solid"/>
+                      <a:round/>
+                      <a:headEnd type="none" w="med" len="med"/>
+                      <a:tailEnd type="none" w="med" len="med"/>
+                    </a:lnL>
+                    <a:lnR w="9525" cap="flat" cmpd="sng" algn="ctr">
+                      <a:solidFill>
+                        <a:srgbClr val="E2E8F0"/>
+                      </a:solidFill>
+                      <a:prstDash val="solid"/>
+                      <a:round/>
+                      <a:headEnd type="none" w="med" len="med"/>
+                      <a:tailEnd type="none" w="med" len="med"/>
+                    </a:lnR>
+                    <a:lnT w="9525" cap="flat" cmpd="sng" algn="ctr">
+                      <a:solidFill>
+                        <a:srgbClr val="E2E8F0"/>
+                      </a:solidFill>
+                      <a:prstDash val="solid"/>
+                      <a:round/>
+                      <a:headEnd type="none" w="med" len="med"/>
+                      <a:tailEnd type="none" w="med" len="med"/>
+                    </a:lnT>
+                    <a:lnB w="9525" cap="flat" cmpd="sng" algn="ctr">
+                      <a:solidFill>
+                        <a:srgbClr val="E2E8F0"/>
+                      </a:solidFill>
+                      <a:prstDash val="solid"/>
+                      <a:round/>
+                      <a:headEnd type="none" w="med" len="med"/>
+                      <a:tailEnd type="none" w="med" len="med"/>
+                    </a:lnB>
+                    <a:solidFill>
+                      <a:srgbClr val="FFFFFF"/>
+                    </a:solidFill>
+                  </a:tcPr>
+                </a:tc>
+                <a:tc>
+                  <a:txBody>
+                    <a:bodyPr/>
+                    <a:lstStyle/>
+                    <a:p>
+                      <a:pPr indent="0" marL="0">
+                        <a:buNone/>
+                      </a:pPr>
+                      <a:r>
+                        <a:rPr lang="en-US" sz="1100" dirty="0">
+                          <a:solidFill>
+                            <a:srgbClr val="0F172A"/>
+                          </a:solidFill>
+                          <a:latin typeface="Segoe UI" pitchFamily="34" charset="0"/>
+                          <a:ea typeface="Segoe UI" pitchFamily="34" charset="-122"/>
+                          <a:cs typeface="Segoe UI" pitchFamily="34" charset="-120"/>
+                        </a:rPr>
+                        <a:t>Tạo trường + admin trường, dashboard usage xuyên trường</a:t>
+                      </a:r>
+                      <a:endParaRPr lang="en-US" sz="1100" dirty="0">
+                        <a:latin typeface="Segoe UI" charset="0"/>
+                        <a:ea typeface="Segoe UI" charset="0"/>
+                        <a:cs typeface="Segoe UI" charset="0"/>
+                      </a:endParaRPr>
+                    </a:p>
+                  </a:txBody>
+                  <a:tcPr marL="73152" marR="73152" marT="73152" marB="73152" anchor="ctr">
+                    <a:lnL w="9525" cap="flat" cmpd="sng" algn="ctr">
+                      <a:solidFill>
+                        <a:srgbClr val="E2E8F0"/>
+                      </a:solidFill>
+                      <a:prstDash val="solid"/>
+                      <a:round/>
+                      <a:headEnd type="none" w="med" len="med"/>
+                      <a:tailEnd type="none" w="med" len="med"/>
+                    </a:lnL>
+                    <a:lnR w="9525" cap="flat" cmpd="sng" algn="ctr">
+                      <a:solidFill>
+                        <a:srgbClr val="E2E8F0"/>
+                      </a:solidFill>
+                      <a:prstDash val="solid"/>
+                      <a:round/>
+                      <a:headEnd type="none" w="med" len="med"/>
+                      <a:tailEnd type="none" w="med" len="med"/>
+                    </a:lnR>
+                    <a:lnT w="9525" cap="flat" cmpd="sng" algn="ctr">
+                      <a:solidFill>
+                        <a:srgbClr val="E2E8F0"/>
+                      </a:solidFill>
+                      <a:prstDash val="solid"/>
+                      <a:round/>
+                      <a:headEnd type="none" w="med" len="med"/>
+                      <a:tailEnd type="none" w="med" len="med"/>
+                    </a:lnT>
+                    <a:lnB w="9525" cap="flat" cmpd="sng" algn="ctr">
+                      <a:solidFill>
+                        <a:srgbClr val="E2E8F0"/>
+                      </a:solidFill>
+                      <a:prstDash val="solid"/>
+                      <a:round/>
+                      <a:headEnd type="none" w="med" len="med"/>
+                      <a:tailEnd type="none" w="med" len="med"/>
+                    </a:lnB>
+                    <a:solidFill>
+                      <a:srgbClr val="FFFFFF"/>
+                    </a:solidFill>
+                  </a:tcPr>
+                </a:tc>
+              </a:tr>
             </a:tbl>
           </a:graphicData>
         </a:graphic>
@@ -9034,6 +9878,27 @@
             </a:r>
             <a:endParaRPr lang="en-US" sz="1250" dirty="0"/>
           </a:p>
+          <a:p>
+            <a:pPr marL="177800" indent="-177800">
+              <a:spcAft>
+                <a:spcPts val="800"/>
+              </a:spcAft>
+              <a:buSzPct val="100000"/>
+              <a:buChar char="•"/>
+            </a:pPr>
+            <a:r>
+              <a:rPr lang="en-US" sz="1250" dirty="0">
+                <a:solidFill>
+                  <a:srgbClr val="0F172A"/>
+                </a:solidFill>
+                <a:latin typeface="Segoe UI" pitchFamily="34" charset="0"/>
+                <a:ea typeface="Segoe UI" pitchFamily="34" charset="-122"/>
+                <a:cs typeface="Segoe UI" pitchFamily="34" charset="-120"/>
+              </a:rPr>
+              <a:t>Sở GD&amp;ĐT / admin hệ thống: quản trị trường (/dept/schools) + giám sát usage (/dept/usage) - không vào nghiệp vụ lớp</a:t>
+            </a:r>
+            <a:endParaRPr lang="en-US" sz="1250" dirty="0"/>
+          </a:p>
         </p:txBody>
       </p:sp>
       <p:sp>
@@ -9323,6 +10188,69 @@
                 <a:cs typeface="Segoe UI" pitchFamily="34" charset="-120"/>
               </a:rPr>
               <a:t>Liên lạc PH: /parents/compose - soạn + gửi email cho CMHS (Resend), thông báo toàn lớp</a:t>
+            </a:r>
+            <a:endParaRPr lang="en-US" sz="1350" dirty="0"/>
+          </a:p>
+          <a:p>
+            <a:pPr marL="177800" indent="-177800">
+              <a:spcAft>
+                <a:spcPts val="800"/>
+              </a:spcAft>
+              <a:buSzPct val="100000"/>
+              <a:buChar char="•"/>
+            </a:pPr>
+            <a:r>
+              <a:rPr lang="en-US" sz="1350" dirty="0">
+                <a:solidFill>
+                  <a:srgbClr val="0F172A"/>
+                </a:solidFill>
+                <a:latin typeface="Segoe UI" pitchFamily="34" charset="0"/>
+                <a:ea typeface="Segoe UI" pitchFamily="34" charset="-122"/>
+                <a:cs typeface="Segoe UI" pitchFamily="34" charset="-120"/>
+              </a:rPr>
+              <a:t>Phụ huynh: /register/roster - liên kết PH - HS và cấp tài khoản đăng nhập cổng PH (tick 'Cấp tài khoản', nhập email + mật khẩu)</a:t>
+            </a:r>
+            <a:endParaRPr lang="en-US" sz="1350" dirty="0"/>
+          </a:p>
+          <a:p>
+            <a:pPr marL="177800" indent="-177800">
+              <a:spcAft>
+                <a:spcPts val="800"/>
+              </a:spcAft>
+              <a:buSzPct val="100000"/>
+              <a:buChar char="•"/>
+            </a:pPr>
+            <a:r>
+              <a:rPr lang="en-US" sz="1350" dirty="0">
+                <a:solidFill>
+                  <a:srgbClr val="0F172A"/>
+                </a:solidFill>
+                <a:latin typeface="Segoe UI" pitchFamily="34" charset="0"/>
+                <a:ea typeface="Segoe UI" pitchFamily="34" charset="-122"/>
+                <a:cs typeface="Segoe UI" pitchFamily="34" charset="-120"/>
+              </a:rPr>
+              <a:t>[object Object]</a:t>
+            </a:r>
+            <a:endParaRPr lang="en-US" sz="1350" dirty="0"/>
+          </a:p>
+          <a:p>
+            <a:pPr marL="381000" indent="-381000">
+              <a:spcAft>
+                <a:spcPts val="800"/>
+              </a:spcAft>
+              <a:buSzPct val="100000"/>
+              <a:buChar char="–"/>
+            </a:pPr>
+            <a:r>
+              <a:rPr lang="en-US" sz="1200" dirty="0">
+                <a:solidFill>
+                  <a:srgbClr val="475569"/>
+                </a:solidFill>
+                <a:latin typeface="Segoe UI" pitchFamily="34" charset="0"/>
+                <a:ea typeface="Segoe UI" pitchFamily="34" charset="-122"/>
+                <a:cs typeface="Segoe UI" pitchFamily="34" charset="-120"/>
+              </a:rPr>
+              <a:t>PH login vào /portal/parent chỉ thấy đúng con mình (RLS parent_students)</a:t>
             </a:r>
             <a:endParaRPr lang="en-US" sz="1350" dirty="0"/>
           </a:p>

</xml_diff>

<commit_message>
fix(docs): loai bo [object Object] trong pptx - bullet sub-only khong render ten
bullets() in String(it.t ?? it) -> "[object Object]" khi item chi co sub.
Fix ca gen-user-guide-pptx va gen-demo-pptx; regen 4 file Office,
verify khong con [object trong bat ky pptx/docx nao; bo qua lock file ~$ cua PowerPoint.

Generated with [Devin](https://devin.ai)

Co-Authored-By: Devin <158243242+devin-ai-integration[bot]@users.noreply.github.com>
</commit_message>
<xml_diff>
--- a/docs/handover/USER-GUIDE-vieschool.pptx
+++ b/docs/handover/USER-GUIDE-vieschool.pptx
@@ -2736,27 +2736,6 @@
             <a:endParaRPr lang="en-US" sz="1350" dirty="0"/>
           </a:p>
           <a:p>
-            <a:pPr marL="177800" indent="-177800">
-              <a:spcAft>
-                <a:spcPts val="800"/>
-              </a:spcAft>
-              <a:buSzPct val="100000"/>
-              <a:buChar char="•"/>
-            </a:pPr>
-            <a:r>
-              <a:rPr lang="en-US" sz="1350" dirty="0">
-                <a:solidFill>
-                  <a:srgbClr val="0F172A"/>
-                </a:solidFill>
-                <a:latin typeface="Segoe UI" pitchFamily="34" charset="0"/>
-                <a:ea typeface="Segoe UI" pitchFamily="34" charset="-122"/>
-                <a:cs typeface="Segoe UI" pitchFamily="34" charset="-120"/>
-              </a:rPr>
-              <a:t>[object Object]</a:t>
-            </a:r>
-            <a:endParaRPr lang="en-US" sz="1350" dirty="0"/>
-          </a:p>
-          <a:p>
             <a:pPr marL="381000" indent="-381000">
               <a:spcAft>
                 <a:spcPts val="800"/>
@@ -2795,27 +2774,6 @@
                 <a:cs typeface="Segoe UI" pitchFamily="34" charset="-120"/>
               </a:rPr>
               <a:t>DC-03: chọn ma trận → rút câu từ ngân hàng CỦA TRƯỜNG → đề chính + đề dự phòng + bảng đáp án</a:t>
-            </a:r>
-            <a:endParaRPr lang="en-US" sz="1350" dirty="0"/>
-          </a:p>
-          <a:p>
-            <a:pPr marL="177800" indent="-177800">
-              <a:spcAft>
-                <a:spcPts val="800"/>
-              </a:spcAft>
-              <a:buSzPct val="100000"/>
-              <a:buChar char="•"/>
-            </a:pPr>
-            <a:r>
-              <a:rPr lang="en-US" sz="1350" dirty="0">
-                <a:solidFill>
-                  <a:srgbClr val="0F172A"/>
-                </a:solidFill>
-                <a:latin typeface="Segoe UI" pitchFamily="34" charset="0"/>
-                <a:ea typeface="Segoe UI" pitchFamily="34" charset="-122"/>
-                <a:cs typeface="Segoe UI" pitchFamily="34" charset="-120"/>
-              </a:rPr>
-              <a:t>[object Object]</a:t>
             </a:r>
             <a:endParaRPr lang="en-US" sz="1350" dirty="0"/>
           </a:p>
@@ -4704,27 +4662,6 @@
             <a:endParaRPr lang="en-US" sz="1350" dirty="0"/>
           </a:p>
           <a:p>
-            <a:pPr marL="177800" indent="-177800">
-              <a:spcAft>
-                <a:spcPts val="800"/>
-              </a:spcAft>
-              <a:buSzPct val="100000"/>
-              <a:buChar char="•"/>
-            </a:pPr>
-            <a:r>
-              <a:rPr lang="en-US" sz="1350" dirty="0">
-                <a:solidFill>
-                  <a:srgbClr val="0F172A"/>
-                </a:solidFill>
-                <a:latin typeface="Segoe UI" pitchFamily="34" charset="0"/>
-                <a:ea typeface="Segoe UI" pitchFamily="34" charset="-122"/>
-                <a:cs typeface="Segoe UI" pitchFamily="34" charset="-120"/>
-              </a:rPr>
-              <a:t>[object Object]</a:t>
-            </a:r>
-            <a:endParaRPr lang="en-US" sz="1350" dirty="0"/>
-          </a:p>
-          <a:p>
             <a:pPr marL="381000" indent="-381000">
               <a:spcAft>
                 <a:spcPts val="800"/>
@@ -4788,27 +4725,6 @@
             <a:endParaRPr lang="en-US" sz="1350" dirty="0"/>
           </a:p>
           <a:p>
-            <a:pPr marL="177800" indent="-177800">
-              <a:spcAft>
-                <a:spcPts val="800"/>
-              </a:spcAft>
-              <a:buSzPct val="100000"/>
-              <a:buChar char="•"/>
-            </a:pPr>
-            <a:r>
-              <a:rPr lang="en-US" sz="1350" dirty="0">
-                <a:solidFill>
-                  <a:srgbClr val="0F172A"/>
-                </a:solidFill>
-                <a:latin typeface="Segoe UI" pitchFamily="34" charset="0"/>
-                <a:ea typeface="Segoe UI" pitchFamily="34" charset="-122"/>
-                <a:cs typeface="Segoe UI" pitchFamily="34" charset="-120"/>
-              </a:rPr>
-              <a:t>[object Object]</a:t>
-            </a:r>
-            <a:endParaRPr lang="en-US" sz="1350" dirty="0"/>
-          </a:p>
-          <a:p>
             <a:pPr marL="381000" indent="-381000">
               <a:spcAft>
                 <a:spcPts val="800"/>
@@ -4847,27 +4763,6 @@
                 <a:cs typeface="Segoe UI" pitchFamily="34" charset="-120"/>
               </a:rPr>
               <a:t>Vai trò kiêm nhiệm áp dụng thật:</a:t>
-            </a:r>
-            <a:endParaRPr lang="en-US" sz="1350" dirty="0"/>
-          </a:p>
-          <a:p>
-            <a:pPr marL="177800" indent="-177800">
-              <a:spcAft>
-                <a:spcPts val="800"/>
-              </a:spcAft>
-              <a:buSzPct val="100000"/>
-              <a:buChar char="•"/>
-            </a:pPr>
-            <a:r>
-              <a:rPr lang="en-US" sz="1350" dirty="0">
-                <a:solidFill>
-                  <a:srgbClr val="0F172A"/>
-                </a:solidFill>
-                <a:latin typeface="Segoe UI" pitchFamily="34" charset="0"/>
-                <a:ea typeface="Segoe UI" pitchFamily="34" charset="-122"/>
-                <a:cs typeface="Segoe UI" pitchFamily="34" charset="-120"/>
-              </a:rPr>
-              <a:t>[object Object]</a:t>
             </a:r>
             <a:endParaRPr lang="en-US" sz="1350" dirty="0"/>
           </a:p>
@@ -5146,27 +5041,6 @@
             <a:endParaRPr lang="en-US" sz="1350" dirty="0"/>
           </a:p>
           <a:p>
-            <a:pPr marL="177800" indent="-177800">
-              <a:spcAft>
-                <a:spcPts val="800"/>
-              </a:spcAft>
-              <a:buSzPct val="100000"/>
-              <a:buChar char="•"/>
-            </a:pPr>
-            <a:r>
-              <a:rPr lang="en-US" sz="1350" dirty="0">
-                <a:solidFill>
-                  <a:srgbClr val="0F172A"/>
-                </a:solidFill>
-                <a:latin typeface="Segoe UI" pitchFamily="34" charset="0"/>
-                <a:ea typeface="Segoe UI" pitchFamily="34" charset="-122"/>
-                <a:cs typeface="Segoe UI" pitchFamily="34" charset="-120"/>
-              </a:rPr>
-              <a:t>[object Object]</a:t>
-            </a:r>
-            <a:endParaRPr lang="en-US" sz="1350" dirty="0"/>
-          </a:p>
-          <a:p>
             <a:pPr marL="381000" indent="-381000">
               <a:spcAft>
                 <a:spcPts val="800"/>
@@ -5399,27 +5273,6 @@
             <a:endParaRPr lang="en-US" sz="1350" dirty="0"/>
           </a:p>
           <a:p>
-            <a:pPr marL="177800" indent="-177800">
-              <a:spcAft>
-                <a:spcPts val="800"/>
-              </a:spcAft>
-              <a:buSzPct val="100000"/>
-              <a:buChar char="•"/>
-            </a:pPr>
-            <a:r>
-              <a:rPr lang="en-US" sz="1350" dirty="0">
-                <a:solidFill>
-                  <a:srgbClr val="0F172A"/>
-                </a:solidFill>
-                <a:latin typeface="Segoe UI" pitchFamily="34" charset="0"/>
-                <a:ea typeface="Segoe UI" pitchFamily="34" charset="-122"/>
-                <a:cs typeface="Segoe UI" pitchFamily="34" charset="-120"/>
-              </a:rPr>
-              <a:t>[object Object]</a:t>
-            </a:r>
-            <a:endParaRPr lang="en-US" sz="1350" dirty="0"/>
-          </a:p>
-          <a:p>
             <a:pPr marL="381000" indent="-381000">
               <a:spcAft>
                 <a:spcPts val="800"/>
@@ -5479,27 +5332,6 @@
                 <a:cs typeface="Segoe UI" pitchFamily="34" charset="-120"/>
               </a:rPr>
               <a:t>Đường 2 - Import Excel hàng loạt (khuyến nghị cho trường lớn):</a:t>
-            </a:r>
-            <a:endParaRPr lang="en-US" sz="1350" dirty="0"/>
-          </a:p>
-          <a:p>
-            <a:pPr marL="177800" indent="-177800">
-              <a:spcAft>
-                <a:spcPts val="800"/>
-              </a:spcAft>
-              <a:buSzPct val="100000"/>
-              <a:buChar char="•"/>
-            </a:pPr>
-            <a:r>
-              <a:rPr lang="en-US" sz="1350" dirty="0">
-                <a:solidFill>
-                  <a:srgbClr val="0F172A"/>
-                </a:solidFill>
-                <a:latin typeface="Segoe UI" pitchFamily="34" charset="0"/>
-                <a:ea typeface="Segoe UI" pitchFamily="34" charset="-122"/>
-                <a:cs typeface="Segoe UI" pitchFamily="34" charset="-120"/>
-              </a:rPr>
-              <a:t>[object Object]</a:t>
             </a:r>
             <a:endParaRPr lang="en-US" sz="1350" dirty="0"/>
           </a:p>
@@ -7374,27 +7206,6 @@
             <a:endParaRPr lang="en-US" sz="1350" dirty="0"/>
           </a:p>
           <a:p>
-            <a:pPr marL="177800" indent="-177800">
-              <a:spcAft>
-                <a:spcPts val="800"/>
-              </a:spcAft>
-              <a:buSzPct val="100000"/>
-              <a:buChar char="•"/>
-            </a:pPr>
-            <a:r>
-              <a:rPr lang="en-US" sz="1350" dirty="0">
-                <a:solidFill>
-                  <a:srgbClr val="0F172A"/>
-                </a:solidFill>
-                <a:latin typeface="Segoe UI" pitchFamily="34" charset="0"/>
-                <a:ea typeface="Segoe UI" pitchFamily="34" charset="-122"/>
-                <a:cs typeface="Segoe UI" pitchFamily="34" charset="-120"/>
-              </a:rPr>
-              <a:t>[object Object]</a:t>
-            </a:r>
-            <a:endParaRPr lang="en-US" sz="1350" dirty="0"/>
-          </a:p>
-          <a:p>
             <a:pPr marL="381000" indent="-381000">
               <a:spcAft>
                 <a:spcPts val="800"/>
@@ -7454,27 +7265,6 @@
                 <a:cs typeface="Segoe UI" pitchFamily="34" charset="-120"/>
               </a:rPr>
               <a:t>TVC360 Studio - công cụ soạn thảo giáo viên</a:t>
-            </a:r>
-            <a:endParaRPr lang="en-US" sz="1350" dirty="0"/>
-          </a:p>
-          <a:p>
-            <a:pPr marL="177800" indent="-177800">
-              <a:spcAft>
-                <a:spcPts val="800"/>
-              </a:spcAft>
-              <a:buSzPct val="100000"/>
-              <a:buChar char="•"/>
-            </a:pPr>
-            <a:r>
-              <a:rPr lang="en-US" sz="1350" dirty="0">
-                <a:solidFill>
-                  <a:srgbClr val="0F172A"/>
-                </a:solidFill>
-                <a:latin typeface="Segoe UI" pitchFamily="34" charset="0"/>
-                <a:ea typeface="Segoe UI" pitchFamily="34" charset="-122"/>
-                <a:cs typeface="Segoe UI" pitchFamily="34" charset="-120"/>
-              </a:rPr>
-              <a:t>[object Object]</a:t>
             </a:r>
             <a:endParaRPr lang="en-US" sz="1350" dirty="0"/>
           </a:p>
@@ -13141,27 +12931,6 @@
             <a:endParaRPr lang="en-US" sz="1350" dirty="0"/>
           </a:p>
           <a:p>
-            <a:pPr marL="177800" indent="-177800">
-              <a:spcAft>
-                <a:spcPts val="800"/>
-              </a:spcAft>
-              <a:buSzPct val="100000"/>
-              <a:buChar char="•"/>
-            </a:pPr>
-            <a:r>
-              <a:rPr lang="en-US" sz="1350" dirty="0">
-                <a:solidFill>
-                  <a:srgbClr val="0F172A"/>
-                </a:solidFill>
-                <a:latin typeface="Segoe UI" pitchFamily="34" charset="0"/>
-                <a:ea typeface="Segoe UI" pitchFamily="34" charset="-122"/>
-                <a:cs typeface="Segoe UI" pitchFamily="34" charset="-120"/>
-              </a:rPr>
-              <a:t>[object Object]</a:t>
-            </a:r>
-            <a:endParaRPr lang="en-US" sz="1350" dirty="0"/>
-          </a:p>
-          <a:p>
             <a:pPr marL="381000" indent="-381000">
               <a:spcAft>
                 <a:spcPts val="800"/>
@@ -13225,27 +12994,6 @@
             <a:endParaRPr lang="en-US" sz="1350" dirty="0"/>
           </a:p>
           <a:p>
-            <a:pPr marL="177800" indent="-177800">
-              <a:spcAft>
-                <a:spcPts val="800"/>
-              </a:spcAft>
-              <a:buSzPct val="100000"/>
-              <a:buChar char="•"/>
-            </a:pPr>
-            <a:r>
-              <a:rPr lang="en-US" sz="1350" dirty="0">
-                <a:solidFill>
-                  <a:srgbClr val="0F172A"/>
-                </a:solidFill>
-                <a:latin typeface="Segoe UI" pitchFamily="34" charset="0"/>
-                <a:ea typeface="Segoe UI" pitchFamily="34" charset="-122"/>
-                <a:cs typeface="Segoe UI" pitchFamily="34" charset="-120"/>
-              </a:rPr>
-              <a:t>[object Object]</a:t>
-            </a:r>
-            <a:endParaRPr lang="en-US" sz="1350" dirty="0"/>
-          </a:p>
-          <a:p>
             <a:pPr marL="381000" indent="-381000">
               <a:spcAft>
                 <a:spcPts val="800"/>
@@ -13326,27 +13074,6 @@
                 <a:cs typeface="Segoe UI" pitchFamily="34" charset="-120"/>
               </a:rPr>
               <a:t>An toàn:</a:t>
-            </a:r>
-            <a:endParaRPr lang="en-US" sz="1350" dirty="0"/>
-          </a:p>
-          <a:p>
-            <a:pPr marL="177800" indent="-177800">
-              <a:spcAft>
-                <a:spcPts val="800"/>
-              </a:spcAft>
-              <a:buSzPct val="100000"/>
-              <a:buChar char="•"/>
-            </a:pPr>
-            <a:r>
-              <a:rPr lang="en-US" sz="1350" dirty="0">
-                <a:solidFill>
-                  <a:srgbClr val="0F172A"/>
-                </a:solidFill>
-                <a:latin typeface="Segoe UI" pitchFamily="34" charset="0"/>
-                <a:ea typeface="Segoe UI" pitchFamily="34" charset="-122"/>
-                <a:cs typeface="Segoe UI" pitchFamily="34" charset="-120"/>
-              </a:rPr>
-              <a:t>[object Object]</a:t>
             </a:r>
             <a:endParaRPr lang="en-US" sz="1350" dirty="0"/>
           </a:p>
@@ -17207,27 +16934,6 @@
             <a:endParaRPr lang="en-US" sz="1350" dirty="0"/>
           </a:p>
           <a:p>
-            <a:pPr marL="177800" indent="-177800">
-              <a:spcAft>
-                <a:spcPts val="800"/>
-              </a:spcAft>
-              <a:buSzPct val="100000"/>
-              <a:buChar char="•"/>
-            </a:pPr>
-            <a:r>
-              <a:rPr lang="en-US" sz="1350" dirty="0">
-                <a:solidFill>
-                  <a:srgbClr val="0F172A"/>
-                </a:solidFill>
-                <a:latin typeface="Segoe UI" pitchFamily="34" charset="0"/>
-                <a:ea typeface="Segoe UI" pitchFamily="34" charset="-122"/>
-                <a:cs typeface="Segoe UI" pitchFamily="34" charset="-120"/>
-              </a:rPr>
-              <a:t>[object Object]</a:t>
-            </a:r>
-            <a:endParaRPr lang="en-US" sz="1350" dirty="0"/>
-          </a:p>
-          <a:p>
             <a:pPr marL="381000" indent="-381000">
               <a:spcAft>
                 <a:spcPts val="800"/>
@@ -17287,27 +16993,6 @@
                 <a:cs typeface="Segoe UI" pitchFamily="34" charset="-120"/>
               </a:rPr>
               <a:t>Liên lạc PH: /parents/compose - soạn + gửi email cho CMHS (Resend)</a:t>
-            </a:r>
-            <a:endParaRPr lang="en-US" sz="1350" dirty="0"/>
-          </a:p>
-          <a:p>
-            <a:pPr marL="177800" indent="-177800">
-              <a:spcAft>
-                <a:spcPts val="800"/>
-              </a:spcAft>
-              <a:buSzPct val="100000"/>
-              <a:buChar char="•"/>
-            </a:pPr>
-            <a:r>
-              <a:rPr lang="en-US" sz="1350" dirty="0">
-                <a:solidFill>
-                  <a:srgbClr val="0F172A"/>
-                </a:solidFill>
-                <a:latin typeface="Segoe UI" pitchFamily="34" charset="0"/>
-                <a:ea typeface="Segoe UI" pitchFamily="34" charset="-122"/>
-                <a:cs typeface="Segoe UI" pitchFamily="34" charset="-120"/>
-              </a:rPr>
-              <a:t>[object Object]</a:t>
             </a:r>
             <a:endParaRPr lang="en-US" sz="1350" dirty="0"/>
           </a:p>
@@ -17544,27 +17229,6 @@
             <a:endParaRPr lang="en-US" sz="1350" dirty="0"/>
           </a:p>
           <a:p>
-            <a:pPr marL="177800" indent="-177800">
-              <a:spcAft>
-                <a:spcPts val="800"/>
-              </a:spcAft>
-              <a:buSzPct val="100000"/>
-              <a:buChar char="•"/>
-            </a:pPr>
-            <a:r>
-              <a:rPr lang="en-US" sz="1350" dirty="0">
-                <a:solidFill>
-                  <a:srgbClr val="0F172A"/>
-                </a:solidFill>
-                <a:latin typeface="Segoe UI" pitchFamily="34" charset="0"/>
-                <a:ea typeface="Segoe UI" pitchFamily="34" charset="-122"/>
-                <a:cs typeface="Segoe UI" pitchFamily="34" charset="-120"/>
-              </a:rPr>
-              <a:t>[object Object]</a:t>
-            </a:r>
-            <a:endParaRPr lang="en-US" sz="1350" dirty="0"/>
-          </a:p>
-          <a:p>
             <a:pPr marL="381000" indent="-381000">
               <a:spcAft>
                 <a:spcPts val="800"/>
@@ -17878,27 +17542,6 @@
             <a:endParaRPr lang="en-US" sz="1350" dirty="0"/>
           </a:p>
           <a:p>
-            <a:pPr marL="177800" indent="-177800">
-              <a:spcAft>
-                <a:spcPts val="800"/>
-              </a:spcAft>
-              <a:buSzPct val="100000"/>
-              <a:buChar char="•"/>
-            </a:pPr>
-            <a:r>
-              <a:rPr lang="en-US" sz="1350" dirty="0">
-                <a:solidFill>
-                  <a:srgbClr val="0F172A"/>
-                </a:solidFill>
-                <a:latin typeface="Segoe UI" pitchFamily="34" charset="0"/>
-                <a:ea typeface="Segoe UI" pitchFamily="34" charset="-122"/>
-                <a:cs typeface="Segoe UI" pitchFamily="34" charset="-120"/>
-              </a:rPr>
-              <a:t>[object Object]</a:t>
-            </a:r>
-            <a:endParaRPr lang="en-US" sz="1350" dirty="0"/>
-          </a:p>
-          <a:p>
             <a:pPr marL="381000" indent="-381000">
               <a:spcAft>
                 <a:spcPts val="800"/>
@@ -17937,27 +17580,6 @@
                 <a:cs typeface="Segoe UI" pitchFamily="34" charset="-120"/>
               </a:rPr>
               <a:t>Output đúng biểu mẫu: I. Mục tiêu - II. Thiết bị DH - III. Tiến trình - IV. Điều chỉnh + Ký duyệt</a:t>
-            </a:r>
-            <a:endParaRPr lang="en-US" sz="1350" dirty="0"/>
-          </a:p>
-          <a:p>
-            <a:pPr marL="177800" indent="-177800">
-              <a:spcAft>
-                <a:spcPts val="800"/>
-              </a:spcAft>
-              <a:buSzPct val="100000"/>
-              <a:buChar char="•"/>
-            </a:pPr>
-            <a:r>
-              <a:rPr lang="en-US" sz="1350" dirty="0">
-                <a:solidFill>
-                  <a:srgbClr val="0F172A"/>
-                </a:solidFill>
-                <a:latin typeface="Segoe UI" pitchFamily="34" charset="0"/>
-                <a:ea typeface="Segoe UI" pitchFamily="34" charset="-122"/>
-                <a:cs typeface="Segoe UI" pitchFamily="34" charset="-120"/>
-              </a:rPr>
-              <a:t>[object Object]</a:t>
             </a:r>
             <a:endParaRPr lang="en-US" sz="1350" dirty="0"/>
           </a:p>

</xml_diff>

<commit_message>
docs: sync decks with latest state (CR-053/054/056/057/058)
- user-guide: Turnstile login note + export velocity cap 20/h/uid
- arch deck: restore 3-layer security slide + new 'Limitations & handling
  difficulty' slide (edge-tts datacenter block, shared DB noisy neighbor,
  bare auth.uid wrap, scrape caps, poll-based AI jobs, SPOF)

Generated with [Devin](https://devin.ai)

Co-Authored-By: Devin <158243242+devin-ai-integration[bot]@users.noreply.github.com>
</commit_message>
<xml_diff>
--- a/docs/handover/USER-GUIDE-vieschool.pptx
+++ b/docs/handover/USER-GUIDE-vieschool.pptx
@@ -6561,7 +6561,46 @@
       </p:sp>
       <p:sp>
         <p:nvSpPr>
-          <p:cNvPr id="5" name="Shape 3"/>
+          <p:cNvPr id="5" name="Text 3"/>
+          <p:cNvSpPr/>
+          <p:nvPr/>
+        </p:nvSpPr>
+        <p:spPr>
+          <a:xfrm>
+            <a:off x="502920" y="1170432"/>
+            <a:ext cx="11155680" cy="411480"/>
+          </a:xfrm>
+          <a:prstGeom prst="rect">
+            <a:avLst/>
+          </a:prstGeom>
+          <a:noFill/>
+          <a:ln/>
+        </p:spPr>
+        <p:txBody>
+          <a:bodyPr wrap="square" rtlCol="0" anchor="ctr"/>
+          <a:lstStyle/>
+          <a:p>
+            <a:pPr indent="0" marL="0">
+              <a:buNone/>
+            </a:pPr>
+            <a:r>
+              <a:rPr lang="en-US" sz="1250" dirty="0">
+                <a:solidFill>
+                  <a:srgbClr val="475569"/>
+                </a:solidFill>
+                <a:latin typeface="Segoe UI" pitchFamily="34" charset="0"/>
+                <a:ea typeface="Segoe UI" pitchFamily="34" charset="-122"/>
+                <a:cs typeface="Segoe UI" pitchFamily="34" charset="-120"/>
+              </a:rPr>
+              <a:t>Đăng nhập có Turnstile chống bot (ẩn - không cần thao tác thêm); giới hạn xuất file tối đa 20 lần/giờ/tài khoản</a:t>
+            </a:r>
+            <a:endParaRPr lang="en-US" sz="1250" dirty="0"/>
+          </a:p>
+        </p:txBody>
+      </p:sp>
+      <p:sp>
+        <p:nvSpPr>
+          <p:cNvPr id="6" name="Shape 4"/>
           <p:cNvSpPr/>
           <p:nvPr/>
         </p:nvSpPr>
@@ -6584,7 +6623,7 @@
       </p:sp>
       <p:sp>
         <p:nvSpPr>
-          <p:cNvPr id="6" name="Text 4"/>
+          <p:cNvPr id="7" name="Text 5"/>
           <p:cNvSpPr/>
           <p:nvPr/>
         </p:nvSpPr>
@@ -6623,7 +6662,7 @@
       </p:sp>
       <p:sp>
         <p:nvSpPr>
-          <p:cNvPr id="7" name="Text 5"/>
+          <p:cNvPr id="8" name="Text 6"/>
           <p:cNvSpPr/>
           <p:nvPr/>
         </p:nvSpPr>
@@ -9982,7 +10021,7 @@
       </p:graphicFrame>
       <p:sp>
         <p:nvSpPr>
-          <p:cNvPr id="9" name="Text 6"/>
+          <p:cNvPr id="10" name="Text 7"/>
           <p:cNvSpPr/>
           <p:nvPr/>
         </p:nvSpPr>
@@ -22037,6 +22076,27 @@
                 <a:cs typeface="Segoe UI" pitchFamily="34" charset="-120"/>
               </a:rPr>
               <a:t>Xuất sổ: CSV toàn bộ dữ liệu sổ chủ nhiệm</a:t>
+            </a:r>
+            <a:endParaRPr lang="en-US" sz="1250" dirty="0"/>
+          </a:p>
+          <a:p>
+            <a:pPr marL="381000" indent="-381000">
+              <a:spcAft>
+                <a:spcPts val="800"/>
+              </a:spcAft>
+              <a:buSzPct val="100000"/>
+              <a:buChar char="–"/>
+            </a:pPr>
+            <a:r>
+              <a:rPr lang="en-US" sz="1100" dirty="0">
+                <a:solidFill>
+                  <a:srgbClr val="475569"/>
+                </a:solidFill>
+                <a:latin typeface="Segoe UI" pitchFamily="34" charset="0"/>
+                <a:ea typeface="Segoe UI" pitchFamily="34" charset="-122"/>
+                <a:cs typeface="Segoe UI" pitchFamily="34" charset="-120"/>
+              </a:rPr>
+              <a:t>Giới hạn chống lạm dụng: tối đa 20 lần xuất/giờ/tài khoản - vượt quá bị tạm khóa + ghi audit</a:t>
             </a:r>
             <a:endParaRPr lang="en-US" sz="1250" dirty="0"/>
           </a:p>

</xml_diff>

<commit_message>
fix+docs: full-SDLC wave verify - raw-error echoes, AC mapping, gap+arch docs
- R7-04/R9-03: mapRpcError/fail helpers chan raw error.message ve client
  (finance, library, lms, portal, hoc-ba, admissions); apply API doi field
  message->error; return-type annotations cho action unions
- tests: sua Windows CRLF (read normalize), pathToFileURL imports, stale
  guards sau CR-056 (TTS sang audio/route.ts), regex khop refactor r33
- RTM 95/95: khai bao AC-62/63/64/66.7/67.x trong CR docs
- docs: COMPETITIVE-GAP-2026-10-28 (vnEdu/SMAS/MISA) + ARCH-1M-USERS
  (modular monolith -> staged microservices, 1M users path)
- e2e-wave-smoke: 11/11 PASS (finance/lms/library/movements/admissions
  render + deny dung role)

Generated with [Devin](https://devin.ai)

Co-Authored-By: Devin <158243242+devin-ai-integration[bot]@users.noreply.github.com>
</commit_message>
<xml_diff>
--- a/docs/handover/USER-GUIDE-vieschool.pptx
+++ b/docs/handover/USER-GUIDE-vieschool.pptx
@@ -22728,9 +22728,9 @@
             <a:prstDash val="solid"/>
           </a:ln>
           <a:effectLst>
-            <a:outerShdw sx="100000" sy="100000" kx="0" ky="0" algn="bl" rotWithShape="0" blurRad="3.730131021158521e+29" dist="1.0657517203310059e+29" dir="2.519424e+35">
+            <a:outerShdw sx="100000" sy="100000" kx="0" ky="0" algn="bl" rotWithShape="0" blurRad="4.737266396871321e+33" dist="1.3535046848203775e+33" dir="1.5116544e+40">
               <a:srgbClr val="000000">
-                <a:alpha val="2.9999999999999997e+34"/>
+                <a:alpha val="3e+39"/>
               </a:srgbClr>
             </a:outerShdw>
           </a:effectLst>
@@ -23567,9 +23567,9 @@
             <a:prstDash val="solid"/>
           </a:ln>
           <a:effectLst>
-            <a:outerShdw sx="100000" sy="100000" kx="0" ky="0" algn="bl" rotWithShape="0" blurRad="4.737266396871321e+33" dist="1.3535046848203775e+33" dir="1.5116544e+40">
+            <a:outerShdw sx="100000" sy="100000" kx="0" ky="0" algn="bl" rotWithShape="0" blurRad="6.016328324026578e+37" dist="1.7189509497218795e+37" dir="9.069926400000001e+44">
               <a:srgbClr val="000000">
-                <a:alpha val="3e+39"/>
+                <a:alpha val="3e+44"/>
               </a:srgbClr>
             </a:outerShdw>
           </a:effectLst>
@@ -23997,9 +23997,9 @@
             <a:prstDash val="solid"/>
           </a:ln>
           <a:effectLst>
-            <a:outerShdw sx="100000" sy="100000" kx="0" ky="0" algn="bl" rotWithShape="0" blurRad="6.016328324026578e+37" dist="1.7189509497218795e+37" dir="9.069926400000001e+44">
+            <a:outerShdw sx="100000" sy="100000" kx="0" ky="0" algn="bl" rotWithShape="0" blurRad="7.640736971513755e+41" dist="2.183067706146787e+41" dir="5.44195584e+49">
               <a:srgbClr val="000000">
-                <a:alpha val="3e+44"/>
+                <a:alpha val="2.9999999999999997e+49"/>
               </a:srgbClr>
             </a:outerShdw>
           </a:effectLst>
@@ -24406,9 +24406,9 @@
             <a:prstDash val="solid"/>
           </a:ln>
           <a:effectLst>
-            <a:outerShdw sx="100000" sy="100000" kx="0" ky="0" algn="bl" rotWithShape="0" blurRad="7.640736971513755e+41" dist="2.183067706146787e+41" dir="5.44195584e+49">
+            <a:outerShdw sx="100000" sy="100000" kx="0" ky="0" algn="bl" rotWithShape="0" blurRad="9.703735953822469e+45" dist="2.7724959868064195e+45" dir="3.2651735040000005e+54">
               <a:srgbClr val="000000">
-                <a:alpha val="2.9999999999999997e+49"/>
+                <a:alpha val="2.9999999999999996e+54"/>
               </a:srgbClr>
             </a:outerShdw>
           </a:effectLst>
@@ -24857,9 +24857,9 @@
             <a:prstDash val="solid"/>
           </a:ln>
           <a:effectLst>
-            <a:outerShdw sx="100000" sy="100000" kx="0" ky="0" algn="bl" rotWithShape="0" blurRad="9.703735953822469e+45" dist="2.7724959868064195e+45" dir="3.2651735040000005e+54">
+            <a:outerShdw sx="100000" sy="100000" kx="0" ky="0" algn="bl" rotWithShape="0" blurRad="1.2323744661354536e+50" dist="3.5210699032441527e+49" dir="1.9591041024000004e+59">
               <a:srgbClr val="000000">
-                <a:alpha val="2.9999999999999996e+54"/>
+                <a:alpha val="2.9999999999999996e+59"/>
               </a:srgbClr>
             </a:outerShdw>
           </a:effectLst>
@@ -25812,9 +25812,9 @@
             <a:prstDash val="solid"/>
           </a:ln>
           <a:effectLst>
-            <a:outerShdw sx="100000" sy="100000" kx="0" ky="0" algn="bl" rotWithShape="0" blurRad="1.2323744661354536e+50" dist="3.5210699032441527e+49" dir="1.9591041024000004e+59">
+            <a:outerShdw sx="100000" sy="100000" kx="0" ky="0" algn="bl" rotWithShape="0" blurRad="1.5651155719920262e+54" dist="4.471758777120074e+53" dir="1.1754624614400003e+64">
               <a:srgbClr val="000000">
-                <a:alpha val="2.9999999999999996e+59"/>
+                <a:alpha val="2.9999999999999996e+64"/>
               </a:srgbClr>
             </a:outerShdw>
           </a:effectLst>
@@ -26242,9 +26242,9 @@
             <a:prstDash val="solid"/>
           </a:ln>
           <a:effectLst>
-            <a:outerShdw sx="100000" sy="100000" kx="0" ky="0" algn="bl" rotWithShape="0" blurRad="1.5651155719920262e+54" dist="4.471758777120074e+53" dir="1.1754624614400003e+64">
+            <a:outerShdw sx="100000" sy="100000" kx="0" ky="0" algn="bl" rotWithShape="0" blurRad="1.9876967764298733e+58" dist="5.679133646942494e+57" dir="7.052774768640002e+68">
               <a:srgbClr val="000000">
-                <a:alpha val="2.9999999999999996e+64"/>
+                <a:alpha val="2.9999999999999995e+69"/>
               </a:srgbClr>
             </a:outerShdw>
           </a:effectLst>
@@ -26693,9 +26693,9 @@
             <a:prstDash val="solid"/>
           </a:ln>
           <a:effectLst>
-            <a:outerShdw sx="100000" sy="100000" kx="0" ky="0" algn="bl" rotWithShape="0" blurRad="1.9876967764298733e+58" dist="5.679133646942494e+57" dir="7.052774768640002e+68">
+            <a:outerShdw sx="100000" sy="100000" kx="0" ky="0" algn="bl" rotWithShape="0" blurRad="2.524374906065939e+62" dist="7.212499731616968e+61" dir="4.2316648611840007e+73">
               <a:srgbClr val="000000">
-                <a:alpha val="2.9999999999999995e+69"/>
+                <a:alpha val="2.9999999999999995e+74"/>
               </a:srgbClr>
             </a:outerShdw>
           </a:effectLst>
@@ -27144,9 +27144,9 @@
             <a:prstDash val="solid"/>
           </a:ln>
           <a:effectLst>
-            <a:outerShdw sx="100000" sy="100000" kx="0" ky="0" algn="bl" rotWithShape="0" blurRad="2.524374906065939e+62" dist="7.212499731616968e+61" dir="4.2316648611840007e+73">
+            <a:outerShdw sx="100000" sy="100000" kx="0" ky="0" algn="bl" rotWithShape="0" blurRad="3.2059561307037426e+66" dist="9.15987465915355e+65" dir="2.5389989167104004e+78">
               <a:srgbClr val="000000">
-                <a:alpha val="2.9999999999999995e+74"/>
+                <a:alpha val="3e+79"/>
               </a:srgbClr>
             </a:outerShdw>
           </a:effectLst>
@@ -28025,9 +28025,9 @@
             <a:prstDash val="solid"/>
           </a:ln>
           <a:effectLst>
-            <a:outerShdw sx="100000" sy="100000" kx="0" ky="0" algn="bl" rotWithShape="0" blurRad="3.2059561307037426e+66" dist="9.15987465915355e+65" dir="2.5389989167104004e+78">
+            <a:outerShdw sx="100000" sy="100000" kx="0" ky="0" algn="bl" rotWithShape="0" blurRad="4.071564285993753e+70" dist="1.1633040817125008e+70" dir="1.5233993500262402e+83">
               <a:srgbClr val="000000">
-                <a:alpha val="3e+79"/>
+                <a:alpha val="2.9999999999999995e+84"/>
               </a:srgbClr>
             </a:outerShdw>
           </a:effectLst>
@@ -31334,7 +31334,7 @@
         <p:spPr>
           <a:xfrm>
             <a:off x="640080" y="1783080"/>
-            <a:ext cx="10972800" cy="4572000"/>
+            <a:ext cx="5669280" cy="4572000"/>
           </a:xfrm>
           <a:prstGeom prst="rect">
             <a:avLst/>
@@ -31470,6 +31470,103 @@
               <a:t>Phân quyền: GVCN chỉ lớp mình; PHT chỉ cơ sở mình; Sở GD/UBND xem chỉ đọc; HS xem học bạ bản thân trên portal</a:t>
             </a:r>
             <a:endParaRPr lang="en-US" sz="1250" dirty="0"/>
+          </a:p>
+        </p:txBody>
+      </p:sp>
+      <p:sp>
+        <p:nvSpPr>
+          <p:cNvPr id="9" name="Shape 7"/>
+          <p:cNvSpPr/>
+          <p:nvPr/>
+        </p:nvSpPr>
+        <p:spPr>
+          <a:xfrm>
+            <a:off x="6400800" y="1645920"/>
+            <a:ext cx="5394960" cy="3474720"/>
+          </a:xfrm>
+          <a:prstGeom prst="roundRect">
+            <a:avLst>
+              <a:gd name="adj" fmla="val 2105"/>
+            </a:avLst>
+          </a:prstGeom>
+          <a:solidFill>
+            <a:srgbClr val="FFFFFF"/>
+          </a:solidFill>
+          <a:ln w="12700">
+            <a:solidFill>
+              <a:srgbClr val="E2E8F0"/>
+            </a:solidFill>
+            <a:prstDash val="solid"/>
+          </a:ln>
+          <a:effectLst>
+            <a:outerShdw sx="100000" sy="100000" kx="0" ky="0" algn="bl" rotWithShape="0" blurRad="2.31268585849e+21" dist="660767388140000000000" dir="6.9984e+25">
+              <a:srgbClr val="000000">
+                <a:alpha val="3e+24"/>
+              </a:srgbClr>
+            </a:outerShdw>
+          </a:effectLst>
+        </p:spPr>
+      </p:sp>
+      <p:pic>
+        <p:nvPicPr>
+          <p:cNvPr id="10" name="Image 0" descr="docs/user-guide/images/32-hoc-ba-so.png">    </p:cNvPr>
+          <p:cNvPicPr>
+            <a:picLocks noChangeAspect="1"/>
+          </p:cNvPicPr>
+          <p:nvPr/>
+        </p:nvPicPr>
+        <p:blipFill>
+          <a:blip r:embed="rId1"/>
+          <a:stretch>
+            <a:fillRect/>
+          </a:stretch>
+        </p:blipFill>
+        <p:spPr>
+          <a:xfrm>
+            <a:off x="6537960" y="1783080"/>
+            <a:ext cx="5120640" cy="3200400"/>
+          </a:xfrm>
+          <a:prstGeom prst="rect">
+            <a:avLst/>
+          </a:prstGeom>
+        </p:spPr>
+      </p:pic>
+      <p:sp>
+        <p:nvSpPr>
+          <p:cNvPr id="11" name="Text 8"/>
+          <p:cNvSpPr/>
+          <p:nvPr/>
+        </p:nvSpPr>
+        <p:spPr>
+          <a:xfrm>
+            <a:off x="6400800" y="5175504"/>
+            <a:ext cx="5394960" cy="365760"/>
+          </a:xfrm>
+          <a:prstGeom prst="rect">
+            <a:avLst/>
+          </a:prstGeom>
+          <a:noFill/>
+          <a:ln/>
+        </p:spPr>
+        <p:txBody>
+          <a:bodyPr wrap="square" rtlCol="0" anchor="ctr"/>
+          <a:lstStyle/>
+          <a:p>
+            <a:pPr indent="0" marL="0">
+              <a:buNone/>
+            </a:pPr>
+            <a:r>
+              <a:rPr lang="en-US" sz="1000" i="1" dirty="0">
+                <a:solidFill>
+                  <a:srgbClr val="475569"/>
+                </a:solidFill>
+                <a:latin typeface="Segoe UI" pitchFamily="34" charset="0"/>
+                <a:ea typeface="Segoe UI" pitchFamily="34" charset="-122"/>
+                <a:cs typeface="Segoe UI" pitchFamily="34" charset="-120"/>
+              </a:rPr>
+              <a:t>Học bạ số lớp 8A2 - trạng thái duyệt/khóa theo TT22</a:t>
+            </a:r>
+            <a:endParaRPr lang="en-US" sz="1000" dirty="0"/>
           </a:p>
         </p:txBody>
       </p:sp>
@@ -31832,9 +31929,9 @@
             <a:prstDash val="solid"/>
           </a:ln>
           <a:effectLst>
-            <a:outerShdw sx="100000" sy="100000" kx="0" ky="0" algn="bl" rotWithShape="0" blurRad="2.31268585849e+21" dist="660767388140000000000" dir="6.9984e+25">
+            <a:outerShdw sx="100000" sy="100000" kx="0" ky="0" algn="bl" rotWithShape="0" blurRad="2.9371110402823e+25" dist="8.391745829378e+24" dir="4.19904e+30">
               <a:srgbClr val="000000">
-                <a:alpha val="3e+24"/>
+                <a:alpha val="3e+29"/>
               </a:srgbClr>
             </a:outerShdw>
           </a:effectLst>
@@ -32283,9 +32380,9 @@
             <a:prstDash val="solid"/>
           </a:ln>
           <a:effectLst>
-            <a:outerShdw sx="100000" sy="100000" kx="0" ky="0" algn="bl" rotWithShape="0" blurRad="2.9371110402823e+25" dist="8.391745829378e+24" dir="4.19904e+30">
+            <a:outerShdw sx="100000" sy="100000" kx="0" ky="0" algn="bl" rotWithShape="0" blurRad="3.730131021158521e+29" dist="1.0657517203310059e+29" dir="2.519424e+35">
               <a:srgbClr val="000000">
-                <a:alpha val="3e+29"/>
+                <a:alpha val="2.9999999999999997e+34"/>
               </a:srgbClr>
             </a:outerShdw>
           </a:effectLst>

</xml_diff>